<commit_message>
Add Chatbot vs Dedicated Viva Trainer comparative analysis, 30s timer, and cram sheet features across presentation and report
</commit_message>
<xml_diff>
--- a/MedSkill_AI_Final_Presentation.pptx
+++ b/MedSkill_AI_Final_Presentation.pptx
@@ -3148,8 +3148,8 @@
         </p:nvSpPr>
         <p:spPr>
           <a:xfrm>
-            <a:off x="1097280" y="1371600"/>
-            <a:ext cx="9966960" cy="4114800"/>
+            <a:off x="1097280" y="1188720"/>
+            <a:ext cx="9966960" cy="4389120"/>
           </a:xfrm>
           <a:prstGeom prst="rect">
             <a:avLst/>
@@ -3163,22 +3163,22 @@
           <a:lstStyle/>
           <a:p>
             <a:pPr>
-              <a:defRPr sz="1300" b="1">
+              <a:defRPr sz="1200" b="1">
                 <a:solidFill>
                   <a:srgbClr val="0D9488"/>
                 </a:solidFill>
               </a:defRPr>
             </a:pPr>
             <a:r>
-              <a:t>DEPARTMENT OF ROBOTICS &amp; AUTOMATION | BATCH 2024-28 (SEM V)</a:t>
+              <a:t>DEPARTMENT OF ROBOTICS &amp; AUTOMATION | BATCH 2024-28 (SEM V) | CA2 ACTIVITY 13</a:t>
             </a:r>
           </a:p>
           <a:p>
             <a:pPr>
               <a:spcBef>
-                <a:spcPts val="1400"/>
+                <a:spcPts val="1200"/>
               </a:spcBef>
-              <a:defRPr sz="4000" b="1">
+              <a:defRPr sz="3800" b="1">
                 <a:solidFill>
                   <a:srgbClr val="FFFFFF"/>
                 </a:solidFill>
@@ -3191,11 +3191,11 @@
           <a:p>
             <a:pPr>
               <a:spcBef>
-                <a:spcPts val="800"/>
+                <a:spcPts val="600"/>
               </a:spcBef>
-              <a:defRPr sz="2000">
-                <a:solidFill>
-                  <a:srgbClr val="94A3B8"/>
+              <a:defRPr sz="1800">
+                <a:solidFill>
+                  <a:srgbClr val="BAE6FD"/>
                 </a:solidFill>
               </a:defRPr>
             </a:pPr>
@@ -3206,31 +3206,20 @@
           <a:p>
             <a:pPr>
               <a:spcBef>
-                <a:spcPts val="3000"/>
+                <a:spcPts val="1600"/>
               </a:spcBef>
               <a:defRPr sz="1300">
                 <a:solidFill>
-                  <a:srgbClr val="0D9488"/>
-                </a:solidFill>
-              </a:defRPr>
-            </a:pPr>
-            <a:r>
-              <a:t>CA2 — Activity 13: Design for the Unseen | Live Web Platform: https://medskill-ai.streamlit.app/</a:t>
-            </a:r>
-          </a:p>
-          <a:p>
-            <a:pPr>
-              <a:spcBef>
-                <a:spcPts val="1000"/>
-              </a:spcBef>
-              <a:defRPr sz="1200">
-                <a:solidFill>
-                  <a:srgbClr val="FFFFFF"/>
-                </a:solidFill>
-              </a:defRPr>
-            </a:pPr>
-            <a:r>
-              <a:t>Target Disciplines: Respiratory Therapy | Anaesthesia Technology | Dialysis Technology</a:t>
+                  <a:srgbClr val="94A3B8"/>
+                </a:solidFill>
+              </a:defRPr>
+            </a:pPr>
+            <a:r>
+              <a:t>Specialties: Respiratory Therapy | Anaesthesia Technology | Dialysis Technology</a:t>
+            </a:r>
+            <a:br/>
+            <a:r>
+              <a:t>Live Platform: https://medskill-ai.streamlit.app/ | Stanford d.school Design Thinking Framework</a:t>
             </a:r>
           </a:p>
         </p:txBody>
@@ -3261,8 +3250,8 @@
         </p:nvSpPr>
         <p:spPr>
           <a:xfrm>
-            <a:off x="731520" y="457200"/>
-            <a:ext cx="10728655" cy="1097280"/>
+            <a:off x="731520" y="365760"/>
+            <a:ext cx="10728655" cy="1005840"/>
           </a:xfrm>
           <a:prstGeom prst="rect">
             <a:avLst/>
@@ -3276,7 +3265,7 @@
           <a:lstStyle/>
           <a:p>
             <a:r>
-              <a:rPr sz="1100" b="1">
+              <a:rPr sz="1000" b="1">
                 <a:solidFill>
                   <a:srgbClr val="0D9488"/>
                 </a:solidFill>
@@ -3286,12 +3275,12 @@
           </a:p>
           <a:p>
             <a:r>
-              <a:rPr sz="2600" b="1">
+              <a:rPr sz="2400" b="1">
                 <a:solidFill>
                   <a:srgbClr val="0F172A"/>
                 </a:solidFill>
               </a:rPr>
-              <a:t>1. We Thought... Challenging Our First Understanding</a:t>
+              <a:t>1. We Thought... Challenging Our Initial Assumptions</a:t>
             </a:r>
           </a:p>
         </p:txBody>
@@ -3304,698 +3293,8 @@
         </p:nvSpPr>
         <p:spPr>
           <a:xfrm>
-            <a:off x="731520" y="1828800"/>
-            <a:ext cx="5120640" cy="4389120"/>
-          </a:xfrm>
-          <a:prstGeom prst="roundRect">
-            <a:avLst/>
-          </a:prstGeom>
-          <a:solidFill>
-            <a:srgbClr val="F8FAFC"/>
-          </a:solidFill>
-          <a:ln>
-            <a:solidFill>
-              <a:srgbClr val="E2E8F0"/>
-            </a:solidFill>
-          </a:ln>
-        </p:spPr>
-        <p:style>
-          <a:lnRef idx="1">
-            <a:schemeClr val="accent1"/>
-          </a:lnRef>
-          <a:fillRef idx="3">
-            <a:schemeClr val="accent1"/>
-          </a:fillRef>
-          <a:effectRef idx="2">
-            <a:schemeClr val="accent1"/>
-          </a:effectRef>
-          <a:fontRef idx="minor">
-            <a:schemeClr val="lt1"/>
-          </a:fontRef>
-        </p:style>
-        <p:txBody>
-          <a:bodyPr rtlCol="0" anchor="ctr" wrap="square" lIns="365760" rIns="365760" tIns="365760"/>
-          <a:lstStyle/>
-          <a:p>
-            <a:pPr algn="ctr">
-              <a:defRPr b="1" sz="1400">
-                <a:solidFill>
-                  <a:srgbClr val="DC2626"/>
-                </a:solidFill>
-              </a:defRPr>
-            </a:pPr>
-            <a:r>
-              <a:t>WHAT WE INITIALLY THOUGHT</a:t>
-            </a:r>
-          </a:p>
-          <a:p>
-            <a:pPr>
-              <a:spcBef>
-                <a:spcPts val="1000"/>
-              </a:spcBef>
-              <a:defRPr sz="1200">
-                <a:solidFill>
-                  <a:srgbClr val="0F172A"/>
-                </a:solidFill>
-              </a:defRPr>
-            </a:pPr>
-            <a:r>
-              <a:t>• Students fail clinical vivas because they lack reference notes or textbook question banks.</a:t>
-            </a:r>
-          </a:p>
-          <a:p>
-            <a:pPr>
-              <a:spcBef>
-                <a:spcPts val="1000"/>
-              </a:spcBef>
-              <a:defRPr sz="1200">
-                <a:solidFill>
-                  <a:srgbClr val="0F172A"/>
-                </a:solidFill>
-              </a:defRPr>
-            </a:pPr>
-            <a:r>
-              <a:t>• The obvious solution was compiling another massive PDF question bank or digital flashcard app.</a:t>
-            </a:r>
-          </a:p>
-          <a:p>
-            <a:pPr>
-              <a:spcBef>
-                <a:spcPts val="1000"/>
-              </a:spcBef>
-              <a:defRPr sz="1200">
-                <a:solidFill>
-                  <a:srgbClr val="0F172A"/>
-                </a:solidFill>
-              </a:defRPr>
-            </a:pPr>
-            <a:r>
-              <a:t>• Students who operate equipment during 8-hour hospital postings naturally understand the underlying machine physics.</a:t>
-            </a:r>
-          </a:p>
-          <a:p>
-            <a:pPr>
-              <a:spcBef>
-                <a:spcPts val="1000"/>
-              </a:spcBef>
-              <a:defRPr sz="1200">
-                <a:solidFill>
-                  <a:srgbClr val="0F172A"/>
-                </a:solidFill>
-              </a:defRPr>
-            </a:pPr>
-            <a:r>
-              <a:t>• Rote memorization of hospital SOPs is sufficient for university examinations.</a:t>
-            </a:r>
-          </a:p>
-        </p:txBody>
-      </p:sp>
-      <p:sp>
-        <p:nvSpPr>
-          <p:cNvPr id="4" name="Rounded Rectangle 3"/>
-          <p:cNvSpPr/>
-          <p:nvPr/>
-        </p:nvSpPr>
-        <p:spPr>
-          <a:xfrm>
-            <a:off x="6217920" y="1828800"/>
-            <a:ext cx="5212080" cy="4389120"/>
-          </a:xfrm>
-          <a:prstGeom prst="roundRect">
-            <a:avLst/>
-          </a:prstGeom>
-          <a:solidFill>
-            <a:srgbClr val="F8FAFC"/>
-          </a:solidFill>
-          <a:ln>
-            <a:solidFill>
-              <a:srgbClr val="E2E8F0"/>
-            </a:solidFill>
-          </a:ln>
-        </p:spPr>
-        <p:style>
-          <a:lnRef idx="1">
-            <a:schemeClr val="accent1"/>
-          </a:lnRef>
-          <a:fillRef idx="3">
-            <a:schemeClr val="accent1"/>
-          </a:fillRef>
-          <a:effectRef idx="2">
-            <a:schemeClr val="accent1"/>
-          </a:effectRef>
-          <a:fontRef idx="minor">
-            <a:schemeClr val="lt1"/>
-          </a:fontRef>
-        </p:style>
-        <p:txBody>
-          <a:bodyPr rtlCol="0" anchor="ctr" wrap="square" lIns="365760" rIns="365760" tIns="365760"/>
-          <a:lstStyle/>
-          <a:p>
-            <a:pPr algn="ctr">
-              <a:defRPr b="1" sz="1400">
-                <a:solidFill>
-                  <a:srgbClr val="0284C7"/>
-                </a:solidFill>
-              </a:defRPr>
-            </a:pPr>
-            <a:r>
-              <a:t>THE UNSEEN STAKEHOLDER</a:t>
-            </a:r>
-          </a:p>
-          <a:p>
-            <a:pPr>
-              <a:spcBef>
-                <a:spcPts val="1000"/>
-              </a:spcBef>
-              <a:defRPr sz="1200">
-                <a:solidFill>
-                  <a:srgbClr val="0F172A"/>
-                </a:solidFill>
-              </a:defRPr>
-            </a:pPr>
-            <a:r>
-              <a:t>• Undergraduate technologists in Respiratory, Anaesthesia, and Dialysis technology.</a:t>
-            </a:r>
-          </a:p>
-          <a:p>
-            <a:pPr>
-              <a:spcBef>
-                <a:spcPts val="1000"/>
-              </a:spcBef>
-              <a:defRPr sz="1200">
-                <a:solidFill>
-                  <a:srgbClr val="0F172A"/>
-                </a:solidFill>
-              </a:defRPr>
-            </a:pPr>
-            <a:r>
-              <a:t>• They operate complex life-support machines (ventilators, absorbers, hemodialyzers) during ICU rotations.</a:t>
-            </a:r>
-          </a:p>
-          <a:p>
-            <a:pPr>
-              <a:spcBef>
-                <a:spcPts val="1000"/>
-              </a:spcBef>
-              <a:defRPr sz="1200">
-                <a:solidFill>
-                  <a:srgbClr val="0F172A"/>
-                </a:solidFill>
-              </a:defRPr>
-            </a:pPr>
-            <a:r>
-              <a:t>• Overlooked by mainstream EdTech (which caters only to doctors/MBBS or software coders).</a:t>
-            </a:r>
-          </a:p>
-          <a:p>
-            <a:pPr>
-              <a:spcBef>
-                <a:spcPts val="1000"/>
-              </a:spcBef>
-              <a:defRPr sz="1200">
-                <a:solidFill>
-                  <a:srgbClr val="0F172A"/>
-                </a:solidFill>
-              </a:defRPr>
-            </a:pPr>
-            <a:r>
-              <a:t>• Experience extreme verbal paralysis when external university examiners ask them to explain physical laws aloud.</a:t>
-            </a:r>
-          </a:p>
-        </p:txBody>
-      </p:sp>
-    </p:spTree>
-  </p:cSld>
-  <p:clrMapOvr>
-    <a:masterClrMapping/>
-  </p:clrMapOvr>
-</p:sld>
-</file>
-
-<file path=ppt/slides/slide3.xml><?xml version="1.0" encoding="utf-8"?>
-<p:sld xmlns:a="http://schemas.openxmlformats.org/drawingml/2006/main" xmlns:p="http://schemas.openxmlformats.org/presentationml/2006/main" xmlns:r="http://schemas.openxmlformats.org/officeDocument/2006/relationships">
-  <p:cSld>
-    <p:spTree>
-      <p:nvGrpSpPr>
-        <p:cNvPr id="1" name=""/>
-        <p:cNvGrpSpPr/>
-        <p:nvPr/>
-      </p:nvGrpSpPr>
-      <p:grpSpPr/>
-      <p:sp>
-        <p:nvSpPr>
-          <p:cNvPr id="2" name="TextBox 1"/>
-          <p:cNvSpPr txBox="1"/>
-          <p:nvPr/>
-        </p:nvSpPr>
-        <p:spPr>
-          <a:xfrm>
-            <a:off x="731520" y="457200"/>
-            <a:ext cx="10728655" cy="1097280"/>
-          </a:xfrm>
-          <a:prstGeom prst="rect">
-            <a:avLst/>
-          </a:prstGeom>
-          <a:noFill/>
-        </p:spPr>
-        <p:txBody>
-          <a:bodyPr wrap="square" lIns="0" tIns="0" rIns="0" bIns="0">
-            <a:spAutoFit/>
-          </a:bodyPr>
-          <a:lstStyle/>
-          <a:p>
-            <a:r>
-              <a:rPr sz="1100" b="1">
-                <a:solidFill>
-                  <a:srgbClr val="0D9488"/>
-                </a:solidFill>
-              </a:rPr>
-              <a:t>CA2 - ACTIVITY 13: DESIGN FOR THE UNSEEN</a:t>
-            </a:r>
-          </a:p>
-          <a:p>
-            <a:r>
-              <a:rPr sz="2600" b="1">
-                <a:solidFill>
-                  <a:srgbClr val="0F172A"/>
-                </a:solidFill>
-              </a:rPr>
-              <a:t>2. We Observed &amp; Discovered... 25 Real Clinical Bottlenecks</a:t>
-            </a:r>
-          </a:p>
-        </p:txBody>
-      </p:sp>
-      <p:sp>
-        <p:nvSpPr>
-          <p:cNvPr id="3" name="Rounded Rectangle 2"/>
-          <p:cNvSpPr/>
-          <p:nvPr/>
-        </p:nvSpPr>
-        <p:spPr>
-          <a:xfrm>
-            <a:off x="731520" y="1828800"/>
-            <a:ext cx="5120640" cy="2103120"/>
-          </a:xfrm>
-          <a:prstGeom prst="roundRect">
-            <a:avLst/>
-          </a:prstGeom>
-          <a:solidFill>
-            <a:srgbClr val="F8FAFC"/>
-          </a:solidFill>
-          <a:ln>
-            <a:solidFill>
-              <a:srgbClr val="E2E8F0"/>
-            </a:solidFill>
-          </a:ln>
-        </p:spPr>
-        <p:style>
-          <a:lnRef idx="1">
-            <a:schemeClr val="accent1"/>
-          </a:lnRef>
-          <a:fillRef idx="3">
-            <a:schemeClr val="accent1"/>
-          </a:fillRef>
-          <a:effectRef idx="2">
-            <a:schemeClr val="accent1"/>
-          </a:effectRef>
-          <a:fontRef idx="minor">
-            <a:schemeClr val="lt1"/>
-          </a:fontRef>
-        </p:style>
-        <p:txBody>
-          <a:bodyPr rtlCol="0" anchor="ctr" wrap="square" lIns="274320" tIns="274320"/>
-          <a:lstStyle/>
-          <a:p>
-            <a:pPr algn="ctr">
-              <a:defRPr b="1" sz="1300">
-                <a:solidFill>
-                  <a:srgbClr val="0D9488"/>
-                </a:solidFill>
-              </a:defRPr>
-            </a:pPr>
-            <a:r>
-              <a:t>A. Alarm Fatigue &amp; Failures</a:t>
-            </a:r>
-          </a:p>
-          <a:p>
-            <a:pPr>
-              <a:spcBef>
-                <a:spcPts val="400"/>
-              </a:spcBef>
-              <a:defRPr sz="1050">
-                <a:solidFill>
-                  <a:srgbClr val="0F172A"/>
-                </a:solidFill>
-              </a:defRPr>
-            </a:pPr>
-            <a:r>
-              <a:t>Problems: 2, 8, 16, 22</a:t>
-            </a:r>
-            <a:br/>
-            <a:r>
-              <a:t>• Delayed response to ventilator alarms</a:t>
-            </a:r>
-            <a:br/>
-            <a:r>
-              <a:t>• Disconnection during repositioning</a:t>
-            </a:r>
-            <a:br/>
-            <a:r>
-              <a:t>• Severe ICU alarm desensitization</a:t>
-            </a:r>
-            <a:br/>
-            <a:r>
-              <a:t>• Missed patient-ventilator asynchrony</a:t>
-            </a:r>
-          </a:p>
-        </p:txBody>
-      </p:sp>
-      <p:sp>
-        <p:nvSpPr>
-          <p:cNvPr id="4" name="Rounded Rectangle 3"/>
-          <p:cNvSpPr/>
-          <p:nvPr/>
-        </p:nvSpPr>
-        <p:spPr>
-          <a:xfrm>
-            <a:off x="6126480" y="1828800"/>
-            <a:ext cx="5120640" cy="2103120"/>
-          </a:xfrm>
-          <a:prstGeom prst="roundRect">
-            <a:avLst/>
-          </a:prstGeom>
-          <a:solidFill>
-            <a:srgbClr val="F8FAFC"/>
-          </a:solidFill>
-          <a:ln>
-            <a:solidFill>
-              <a:srgbClr val="E2E8F0"/>
-            </a:solidFill>
-          </a:ln>
-        </p:spPr>
-        <p:style>
-          <a:lnRef idx="1">
-            <a:schemeClr val="accent1"/>
-          </a:lnRef>
-          <a:fillRef idx="3">
-            <a:schemeClr val="accent1"/>
-          </a:fillRef>
-          <a:effectRef idx="2">
-            <a:schemeClr val="accent1"/>
-          </a:effectRef>
-          <a:fontRef idx="minor">
-            <a:schemeClr val="lt1"/>
-          </a:fontRef>
-        </p:style>
-        <p:txBody>
-          <a:bodyPr rtlCol="0" anchor="ctr" wrap="square" lIns="274320" tIns="274320"/>
-          <a:lstStyle/>
-          <a:p>
-            <a:pPr algn="ctr">
-              <a:defRPr b="1" sz="1300">
-                <a:solidFill>
-                  <a:srgbClr val="0D9488"/>
-                </a:solidFill>
-              </a:defRPr>
-            </a:pPr>
-            <a:r>
-              <a:t>B. Airway &amp; Patient Hazards</a:t>
-            </a:r>
-          </a:p>
-          <a:p>
-            <a:pPr>
-              <a:spcBef>
-                <a:spcPts val="400"/>
-              </a:spcBef>
-              <a:defRPr sz="1050">
-                <a:solidFill>
-                  <a:srgbClr val="0F172A"/>
-                </a:solidFill>
-              </a:defRPr>
-            </a:pPr>
-            <a:r>
-              <a:t>Problems: 1, 3, 9, 10, 11, 21</a:t>
-            </a:r>
-            <a:br/>
-            <a:r>
-              <a:t>• Dry oxygen humidifier bottles</a:t>
-            </a:r>
-            <a:br/>
-            <a:r>
-              <a:t>• Accidental self-extubation risks</a:t>
-            </a:r>
-            <a:br/>
-            <a:r>
-              <a:t>• Unmonitored NIV mask air leaks</a:t>
-            </a:r>
-            <a:br/>
-            <a:r>
-              <a:t>• Endotracheal tube depth migration</a:t>
-            </a:r>
-          </a:p>
-        </p:txBody>
-      </p:sp>
-      <p:sp>
-        <p:nvSpPr>
-          <p:cNvPr id="5" name="Rounded Rectangle 4"/>
-          <p:cNvSpPr/>
-          <p:nvPr/>
-        </p:nvSpPr>
-        <p:spPr>
-          <a:xfrm>
-            <a:off x="731520" y="4114800"/>
-            <a:ext cx="5120640" cy="2103120"/>
-          </a:xfrm>
-          <a:prstGeom prst="roundRect">
-            <a:avLst/>
-          </a:prstGeom>
-          <a:solidFill>
-            <a:srgbClr val="F8FAFC"/>
-          </a:solidFill>
-          <a:ln>
-            <a:solidFill>
-              <a:srgbClr val="E2E8F0"/>
-            </a:solidFill>
-          </a:ln>
-        </p:spPr>
-        <p:style>
-          <a:lnRef idx="1">
-            <a:schemeClr val="accent1"/>
-          </a:lnRef>
-          <a:fillRef idx="3">
-            <a:schemeClr val="accent1"/>
-          </a:fillRef>
-          <a:effectRef idx="2">
-            <a:schemeClr val="accent1"/>
-          </a:effectRef>
-          <a:fontRef idx="minor">
-            <a:schemeClr val="lt1"/>
-          </a:fontRef>
-        </p:style>
-        <p:txBody>
-          <a:bodyPr rtlCol="0" anchor="ctr" wrap="square" lIns="274320" tIns="274320"/>
-          <a:lstStyle/>
-          <a:p>
-            <a:pPr algn="ctr">
-              <a:defRPr b="1" sz="1300">
-                <a:solidFill>
-                  <a:srgbClr val="0D9488"/>
-                </a:solidFill>
-              </a:defRPr>
-            </a:pPr>
-            <a:r>
-              <a:t>C. Equipment &amp; Transport Risks</a:t>
-            </a:r>
-          </a:p>
-          <a:p>
-            <a:pPr>
-              <a:spcBef>
-                <a:spcPts val="400"/>
-              </a:spcBef>
-              <a:defRPr sz="1050">
-                <a:solidFill>
-                  <a:srgbClr val="0F172A"/>
-                </a:solidFill>
-              </a:defRPr>
-            </a:pPr>
-            <a:r>
-              <a:t>Problems: 12, 14, 18, 24</a:t>
-            </a:r>
-            <a:br/>
-            <a:r>
-              <a:t>• Equipment missing during admissions</a:t>
-            </a:r>
-            <a:br/>
-            <a:r>
-              <a:t>• Cylinder depletion during transport</a:t>
-            </a:r>
-            <a:br/>
-            <a:r>
-              <a:t>• Uncalibrated sensors &amp; expired seals</a:t>
-            </a:r>
-            <a:br/>
-            <a:r>
-              <a:t>• Inadequate monitoring of flowmeters</a:t>
-            </a:r>
-          </a:p>
-        </p:txBody>
-      </p:sp>
-      <p:sp>
-        <p:nvSpPr>
-          <p:cNvPr id="6" name="Rounded Rectangle 5"/>
-          <p:cNvSpPr/>
-          <p:nvPr/>
-        </p:nvSpPr>
-        <p:spPr>
-          <a:xfrm>
-            <a:off x="6126480" y="4114800"/>
-            <a:ext cx="5120640" cy="2103120"/>
-          </a:xfrm>
-          <a:prstGeom prst="roundRect">
-            <a:avLst/>
-          </a:prstGeom>
-          <a:solidFill>
-            <a:srgbClr val="F8FAFC"/>
-          </a:solidFill>
-          <a:ln>
-            <a:solidFill>
-              <a:srgbClr val="E2E8F0"/>
-            </a:solidFill>
-          </a:ln>
-        </p:spPr>
-        <p:style>
-          <a:lnRef idx="1">
-            <a:schemeClr val="accent1"/>
-          </a:lnRef>
-          <a:fillRef idx="3">
-            <a:schemeClr val="accent1"/>
-          </a:fillRef>
-          <a:effectRef idx="2">
-            <a:schemeClr val="accent1"/>
-          </a:effectRef>
-          <a:fontRef idx="minor">
-            <a:schemeClr val="lt1"/>
-          </a:fontRef>
-        </p:style>
-        <p:txBody>
-          <a:bodyPr rtlCol="0" anchor="ctr" wrap="square" lIns="274320" tIns="274320"/>
-          <a:lstStyle/>
-          <a:p>
-            <a:pPr algn="ctr">
-              <a:defRPr b="1" sz="1300">
-                <a:solidFill>
-                  <a:srgbClr val="0D9488"/>
-                </a:solidFill>
-              </a:defRPr>
-            </a:pPr>
-            <a:r>
-              <a:t>D. Data Overload &amp; Reasoning</a:t>
-            </a:r>
-          </a:p>
-          <a:p>
-            <a:pPr>
-              <a:spcBef>
-                <a:spcPts val="400"/>
-              </a:spcBef>
-              <a:defRPr sz="1050">
-                <a:solidFill>
-                  <a:srgbClr val="0F172A"/>
-                </a:solidFill>
-              </a:defRPr>
-            </a:pPr>
-            <a:r>
-              <a:t>Problems: 4, 5, 6, 7, 13, 15, 17, 20</a:t>
-            </a:r>
-            <a:br/>
-            <a:r>
-              <a:t>• Disconnect between ABG and vent settings</a:t>
-            </a:r>
-            <a:br/>
-            <a:r>
-              <a:t>• Incomplete shift handovers</a:t>
-            </a:r>
-            <a:br/>
-            <a:r>
-              <a:t>• Missed spontaneous weaning trials</a:t>
-            </a:r>
-            <a:br/>
-            <a:r>
-              <a:t>• Hours lost on manual paperwork</a:t>
-            </a:r>
-          </a:p>
-        </p:txBody>
-      </p:sp>
-    </p:spTree>
-  </p:cSld>
-  <p:clrMapOvr>
-    <a:masterClrMapping/>
-  </p:clrMapOvr>
-</p:sld>
-</file>
-
-<file path=ppt/slides/slide4.xml><?xml version="1.0" encoding="utf-8"?>
-<p:sld xmlns:a="http://schemas.openxmlformats.org/drawingml/2006/main" xmlns:p="http://schemas.openxmlformats.org/presentationml/2006/main" xmlns:r="http://schemas.openxmlformats.org/officeDocument/2006/relationships">
-  <p:cSld>
-    <p:spTree>
-      <p:nvGrpSpPr>
-        <p:cNvPr id="1" name=""/>
-        <p:cNvGrpSpPr/>
-        <p:nvPr/>
-      </p:nvGrpSpPr>
-      <p:grpSpPr/>
-      <p:sp>
-        <p:nvSpPr>
-          <p:cNvPr id="2" name="TextBox 1"/>
-          <p:cNvSpPr txBox="1"/>
-          <p:nvPr/>
-        </p:nvSpPr>
-        <p:spPr>
-          <a:xfrm>
-            <a:off x="731520" y="457200"/>
-            <a:ext cx="10728655" cy="1097280"/>
-          </a:xfrm>
-          <a:prstGeom prst="rect">
-            <a:avLst/>
-          </a:prstGeom>
-          <a:noFill/>
-        </p:spPr>
-        <p:txBody>
-          <a:bodyPr wrap="square" lIns="0" tIns="0" rIns="0" bIns="0">
-            <a:spAutoFit/>
-          </a:bodyPr>
-          <a:lstStyle/>
-          <a:p>
-            <a:r>
-              <a:rPr sz="1100" b="1">
-                <a:solidFill>
-                  <a:srgbClr val="0D9488"/>
-                </a:solidFill>
-              </a:rPr>
-              <a:t>CA2 - ACTIVITY 13: DESIGN FOR THE UNSEEN</a:t>
-            </a:r>
-          </a:p>
-          <a:p>
-            <a:r>
-              <a:rPr sz="2600" b="1">
-                <a:solidFill>
-                  <a:srgbClr val="0F172A"/>
-                </a:solidFill>
-              </a:rPr>
-              <a:t>3. We Realised the Real Problem Was... Passive Revision Syndrome</a:t>
-            </a:r>
-          </a:p>
-        </p:txBody>
-      </p:sp>
-      <p:sp>
-        <p:nvSpPr>
-          <p:cNvPr id="3" name="Rounded Rectangle 2"/>
-          <p:cNvSpPr/>
-          <p:nvPr/>
-        </p:nvSpPr>
-        <p:spPr>
-          <a:xfrm>
-            <a:off x="1371600" y="1828800"/>
-            <a:ext cx="9418320" cy="4389120"/>
+            <a:off x="731520" y="1645920"/>
+            <a:ext cx="5120640" cy="4572000"/>
           </a:xfrm>
           <a:prstGeom prst="roundRect">
             <a:avLst/>
@@ -4024,493 +3323,83 @@
           </a:fontRef>
         </p:style>
         <p:txBody>
-          <a:bodyPr rtlCol="0" anchor="ctr" wrap="square" lIns="548640" rIns="548640" tIns="548640"/>
+          <a:bodyPr rtlCol="0" anchor="ctr" wrap="square" lIns="365760" rIns="365760" tIns="365760"/>
           <a:lstStyle/>
           <a:p>
             <a:pPr algn="ctr">
-              <a:defRPr b="1" sz="1400">
-                <a:solidFill>
-                  <a:srgbClr val="0284C7"/>
-                </a:solidFill>
-              </a:defRPr>
-            </a:pPr>
-            <a:r>
-              <a:t>THE ROOT CAUSE DISCOVERED BEHIND ALL 25 PROBLEMS:</a:t>
+              <a:defRPr b="1" sz="1300">
+                <a:solidFill>
+                  <a:srgbClr val="64748B"/>
+                </a:solidFill>
+              </a:defRPr>
+            </a:pPr>
+            <a:r>
+              <a:t>WHAT WE INITIALLY THOUGHT</a:t>
             </a:r>
           </a:p>
           <a:p>
             <a:pPr>
               <a:spcBef>
-                <a:spcPts val="1200"/>
+                <a:spcPts val="1000"/>
               </a:spcBef>
-              <a:defRPr sz="1300">
+              <a:defRPr sz="1150">
                 <a:solidFill>
                   <a:srgbClr val="0F172A"/>
                 </a:solidFill>
               </a:defRPr>
             </a:pPr>
             <a:r>
-              <a:t>• Floor Reality vs Exam Reality: In hospital postings, students execute physical tasks mechanically under high pressure. They rarely verbalize *why* a parameter behaves a certain way.</a:t>
+              <a:t>• Initial Assumption: Healthcare technology students fail practical vivas because they lack lecture notes, PPTs, or reference question banks.</a:t>
             </a:r>
           </a:p>
           <a:p>
             <a:pPr>
               <a:spcBef>
-                <a:spcPts val="1200"/>
+                <a:spcPts val="1000"/>
               </a:spcBef>
-              <a:defRPr sz="1300">
+              <a:defRPr sz="1150">
                 <a:solidFill>
                   <a:srgbClr val="0F172A"/>
                 </a:solidFill>
               </a:defRPr>
             </a:pPr>
             <a:r>
-              <a:t>• Passive Revision Syndrome: Students own 500+ pages of PDF notes. Reading creates an illusion of mastery, but fails completely when an external examiner demands immediate oral synthesis.</a:t>
+              <a:t>• Proposed Obvious Fix: Give students more PDF question banks or build a 3D VR ICU room to turn machine knobs.</a:t>
             </a:r>
           </a:p>
           <a:p>
             <a:pPr>
               <a:spcBef>
-                <a:spcPts val="1200"/>
+                <a:spcPts val="1000"/>
               </a:spcBef>
-              <a:defRPr sz="1300">
+              <a:defRPr sz="1150">
                 <a:solidFill>
                   <a:srgbClr val="0F172A"/>
                 </a:solidFill>
               </a:defRPr>
             </a:pPr>
             <a:r>
-              <a:t>• Zero Low-Stakes Practice: There was no accessible digital simulator to test conceptual depth, expose misconceptions, and practice oral articulation before facing university examiners.</a:t>
-            </a:r>
-          </a:p>
-          <a:p>
-            <a:pPr>
-              <a:spcBef>
-                <a:spcPts val="1200"/>
-              </a:spcBef>
-              <a:defRPr sz="1300">
-                <a:solidFill>
-                  <a:srgbClr val="0F172A"/>
-                </a:solidFill>
-              </a:defRPr>
-            </a:pPr>
-            <a:r>
-              <a:t>• Reframed Problem Statement (How Might We): 'How might we build an accessible, interactive digital viva simulator that diagnoses conceptual misunderstandings in healthcare technology students and enables verbal response self-evaluation without requiring complex infrastructure?'</a:t>
-            </a:r>
-          </a:p>
-        </p:txBody>
-      </p:sp>
-    </p:spTree>
-  </p:cSld>
-  <p:clrMapOvr>
-    <a:masterClrMapping/>
-  </p:clrMapOvr>
-</p:sld>
-</file>
-
-<file path=ppt/slides/slide5.xml><?xml version="1.0" encoding="utf-8"?>
-<p:sld xmlns:a="http://schemas.openxmlformats.org/drawingml/2006/main" xmlns:p="http://schemas.openxmlformats.org/presentationml/2006/main" xmlns:r="http://schemas.openxmlformats.org/officeDocument/2006/relationships">
-  <p:cSld>
-    <p:spTree>
-      <p:nvGrpSpPr>
-        <p:cNvPr id="1" name=""/>
-        <p:cNvGrpSpPr/>
-        <p:nvPr/>
-      </p:nvGrpSpPr>
-      <p:grpSpPr/>
-      <p:sp>
-        <p:nvSpPr>
-          <p:cNvPr id="2" name="TextBox 1"/>
-          <p:cNvSpPr txBox="1"/>
+              <a:t>• The Design Thinking Test: In Activity 13 ('Design for the Unseen'), we suspended assumptions and immersed ourselves in the hospital floor.</a:t>
+            </a:r>
+          </a:p>
+        </p:txBody>
+      </p:sp>
+      <p:sp>
+        <p:nvSpPr>
+          <p:cNvPr id="4" name="Rounded Rectangle 3"/>
+          <p:cNvSpPr/>
           <p:nvPr/>
         </p:nvSpPr>
         <p:spPr>
           <a:xfrm>
-            <a:off x="731520" y="457200"/>
-            <a:ext cx="10728655" cy="1097280"/>
-          </a:xfrm>
-          <a:prstGeom prst="rect">
-            <a:avLst/>
-          </a:prstGeom>
-          <a:noFill/>
-        </p:spPr>
-        <p:txBody>
-          <a:bodyPr wrap="square" lIns="0" tIns="0" rIns="0" bIns="0">
-            <a:spAutoFit/>
-          </a:bodyPr>
-          <a:lstStyle/>
-          <a:p>
-            <a:r>
-              <a:rPr sz="1100" b="1">
-                <a:solidFill>
-                  <a:srgbClr val="0D9488"/>
-                </a:solidFill>
-              </a:rPr>
-              <a:t>CA2 - ACTIVITY 13: DESIGN FOR THE UNSEEN</a:t>
-            </a:r>
-          </a:p>
-          <a:p>
-            <a:r>
-              <a:rPr sz="2600" b="1">
-                <a:solidFill>
-                  <a:srgbClr val="0F172A"/>
-                </a:solidFill>
-              </a:rPr>
-              <a:t>4. We Generated 10 Ideas &amp; Killed Our First Solution</a:t>
-            </a:r>
-          </a:p>
-        </p:txBody>
-      </p:sp>
-      <p:sp>
-        <p:nvSpPr>
-          <p:cNvPr id="3" name="Rounded Rectangle 2"/>
-          <p:cNvSpPr/>
-          <p:nvPr/>
-        </p:nvSpPr>
-        <p:spPr>
-          <a:xfrm>
-            <a:off x="731520" y="1828800"/>
-            <a:ext cx="5120640" cy="4389120"/>
+            <a:off x="6217920" y="1645920"/>
+            <a:ext cx="5212080" cy="4572000"/>
           </a:xfrm>
           <a:prstGeom prst="roundRect">
             <a:avLst/>
           </a:prstGeom>
           <a:solidFill>
-            <a:srgbClr val="FEF2F2"/>
-          </a:solidFill>
-          <a:ln>
-            <a:solidFill>
-              <a:srgbClr val="FECACA"/>
-            </a:solidFill>
-          </a:ln>
-        </p:spPr>
-        <p:style>
-          <a:lnRef idx="1">
-            <a:schemeClr val="accent1"/>
-          </a:lnRef>
-          <a:fillRef idx="3">
-            <a:schemeClr val="accent1"/>
-          </a:fillRef>
-          <a:effectRef idx="2">
-            <a:schemeClr val="accent1"/>
-          </a:effectRef>
-          <a:fontRef idx="minor">
-            <a:schemeClr val="lt1"/>
-          </a:fontRef>
-        </p:style>
-        <p:txBody>
-          <a:bodyPr rtlCol="0" anchor="ctr" wrap="square" lIns="365760" tIns="365760"/>
-          <a:lstStyle/>
-          <a:p>
-            <a:pPr algn="ctr">
-              <a:defRPr b="1" sz="1300">
-                <a:solidFill>
-                  <a:srgbClr val="B91C1C"/>
-                </a:solidFill>
-              </a:defRPr>
-            </a:pPr>
-            <a:r>
-              <a:t>KILL YOUR FIRST IDEA: 3D VR KNOB SIMULATOR</a:t>
-            </a:r>
-          </a:p>
-          <a:p>
-            <a:pPr>
-              <a:spcBef>
-                <a:spcPts val="800"/>
-              </a:spcBef>
-              <a:defRPr sz="1150">
-                <a:solidFill>
-                  <a:srgbClr val="0F172A"/>
-                </a:solidFill>
-              </a:defRPr>
-            </a:pPr>
-            <a:r>
-              <a:t>First obvious thought: build a 3D virtual reality simulator where students turn ventilator knobs.</a:t>
-            </a:r>
-          </a:p>
-          <a:p>
-            <a:pPr>
-              <a:spcBef>
-                <a:spcPts val="800"/>
-              </a:spcBef>
-              <a:defRPr sz="1150">
-                <a:solidFill>
-                  <a:srgbClr val="0F172A"/>
-                </a:solidFill>
-              </a:defRPr>
-            </a:pPr>
-            <a:r>
-              <a:t>Why It Failed / Discarded:</a:t>
-            </a:r>
-          </a:p>
-          <a:p>
-            <a:pPr>
-              <a:spcBef>
-                <a:spcPts val="800"/>
-              </a:spcBef>
-              <a:defRPr sz="1150">
-                <a:solidFill>
-                  <a:srgbClr val="0F172A"/>
-                </a:solidFill>
-              </a:defRPr>
-            </a:pPr>
-            <a:r>
-              <a:t>1. Solves the WRONG problem: Students already touch real machines in hospital postings; their real bottleneck is verbal clinical reasoning.</a:t>
-            </a:r>
-          </a:p>
-          <a:p>
-            <a:pPr>
-              <a:spcBef>
-                <a:spcPts val="800"/>
-              </a:spcBef>
-              <a:defRPr sz="1150">
-                <a:solidFill>
-                  <a:srgbClr val="0F172A"/>
-                </a:solidFill>
-              </a:defRPr>
-            </a:pPr>
-            <a:r>
-              <a:t>2. Cost &amp; Access Barrier: VR headsets and high-end GPUs are completely inaccessible to government college students.</a:t>
-            </a:r>
-          </a:p>
-          <a:p>
-            <a:pPr>
-              <a:spcBef>
-                <a:spcPts val="800"/>
-              </a:spcBef>
-              <a:defRPr sz="1150">
-                <a:solidFill>
-                  <a:srgbClr val="0F172A"/>
-                </a:solidFill>
-              </a:defRPr>
-            </a:pPr>
-            <a:r>
-              <a:t>3. High Friction: 2GB+ downloads prevent quick study during 10-minute clinical tea breaks.</a:t>
-            </a:r>
-          </a:p>
-        </p:txBody>
-      </p:sp>
-      <p:sp>
-        <p:nvSpPr>
-          <p:cNvPr id="4" name="Rounded Rectangle 3"/>
-          <p:cNvSpPr/>
-          <p:nvPr/>
-        </p:nvSpPr>
-        <p:spPr>
-          <a:xfrm>
-            <a:off x="6217920" y="1828800"/>
-            <a:ext cx="5212080" cy="4389120"/>
-          </a:xfrm>
-          <a:prstGeom prst="roundRect">
-            <a:avLst/>
-          </a:prstGeom>
-          <a:solidFill>
-            <a:srgbClr val="F0FDF4"/>
-          </a:solidFill>
-          <a:ln>
-            <a:solidFill>
-              <a:srgbClr val="BBF7D0"/>
-            </a:solidFill>
-          </a:ln>
-        </p:spPr>
-        <p:style>
-          <a:lnRef idx="1">
-            <a:schemeClr val="accent1"/>
-          </a:lnRef>
-          <a:fillRef idx="3">
-            <a:schemeClr val="accent1"/>
-          </a:fillRef>
-          <a:effectRef idx="2">
-            <a:schemeClr val="accent1"/>
-          </a:effectRef>
-          <a:fontRef idx="minor">
-            <a:schemeClr val="lt1"/>
-          </a:fontRef>
-        </p:style>
-        <p:txBody>
-          <a:bodyPr rtlCol="0" anchor="ctr" wrap="square" lIns="365760" tIns="365760"/>
-          <a:lstStyle/>
-          <a:p>
-            <a:pPr algn="ctr">
-              <a:defRPr b="1" sz="1300">
-                <a:solidFill>
-                  <a:srgbClr val="15803D"/>
-                </a:solidFill>
-              </a:defRPr>
-            </a:pPr>
-            <a:r>
-              <a:t>10 IDEAS GENERATED -&gt; SELECTED STRATEGY</a:t>
-            </a:r>
-          </a:p>
-          <a:p>
-            <a:pPr>
-              <a:spcBef>
-                <a:spcPts val="800"/>
-              </a:spcBef>
-              <a:defRPr sz="1150">
-                <a:solidFill>
-                  <a:srgbClr val="0F172A"/>
-                </a:solidFill>
-              </a:defRPr>
-            </a:pPr>
-            <a:r>
-              <a:t>Used Brainstorming &amp; SCAMPER across 10 concepts (flashcards, voice bots, peer calling, knob games, mobile apps).</a:t>
-            </a:r>
-          </a:p>
-          <a:p>
-            <a:pPr>
-              <a:spcBef>
-                <a:spcPts val="800"/>
-              </a:spcBef>
-              <a:defRPr sz="1150">
-                <a:solidFill>
-                  <a:srgbClr val="0F172A"/>
-                </a:solidFill>
-              </a:defRPr>
-            </a:pPr>
-            <a:r>
-              <a:t>Key Decisions Made:</a:t>
-            </a:r>
-          </a:p>
-          <a:p>
-            <a:pPr>
-              <a:spcBef>
-                <a:spcPts val="800"/>
-              </a:spcBef>
-              <a:defRPr sz="1150">
-                <a:solidFill>
-                  <a:srgbClr val="0F172A"/>
-                </a:solidFill>
-              </a:defRPr>
-            </a:pPr>
-            <a:r>
-              <a:t>• Idea 4 (Selected): Web-based Dual-Mode Practical Viva Trainer (MCQ + Quick Viva Mode) with zero login friction.</a:t>
-            </a:r>
-          </a:p>
-          <a:p>
-            <a:pPr>
-              <a:spcBef>
-                <a:spcPts val="800"/>
-              </a:spcBef>
-              <a:defRPr sz="1150">
-                <a:solidFill>
-                  <a:srgbClr val="0F172A"/>
-                </a:solidFill>
-              </a:defRPr>
-            </a:pPr>
-            <a:r>
-              <a:t>• Idea 7 (Selected): Targeted Rule-Based Study Recommendations isolating only missed questions.</a:t>
-            </a:r>
-          </a:p>
-          <a:p>
-            <a:pPr>
-              <a:spcBef>
-                <a:spcPts val="800"/>
-              </a:spcBef>
-              <a:defRPr sz="1150">
-                <a:solidFill>
-                  <a:srgbClr val="0F172A"/>
-                </a:solidFill>
-              </a:defRPr>
-            </a:pPr>
-            <a:r>
-              <a:t>• Idea 8 (Selected): Curated 144-Question Verified Curriculum Bank (12 per topic).</a:t>
-            </a:r>
-          </a:p>
-          <a:p>
-            <a:pPr>
-              <a:spcBef>
-                <a:spcPts val="800"/>
-              </a:spcBef>
-              <a:defRPr sz="1150">
-                <a:solidFill>
-                  <a:srgbClr val="0F172A"/>
-                </a:solidFill>
-              </a:defRPr>
-            </a:pPr>
-            <a:r>
-              <a:t>• Idea 9 (Selected): Offline-First Knowledge Engine with optional Gemini LLM fallback.</a:t>
-            </a:r>
-          </a:p>
-        </p:txBody>
-      </p:sp>
-    </p:spTree>
-  </p:cSld>
-  <p:clrMapOvr>
-    <a:masterClrMapping/>
-  </p:clrMapOvr>
-</p:sld>
-</file>
-
-<file path=ppt/slides/slide6.xml><?xml version="1.0" encoding="utf-8"?>
-<p:sld xmlns:a="http://schemas.openxmlformats.org/drawingml/2006/main" xmlns:p="http://schemas.openxmlformats.org/presentationml/2006/main" xmlns:r="http://schemas.openxmlformats.org/officeDocument/2006/relationships">
-  <p:cSld>
-    <p:spTree>
-      <p:nvGrpSpPr>
-        <p:cNvPr id="1" name=""/>
-        <p:cNvGrpSpPr/>
-        <p:nvPr/>
-      </p:nvGrpSpPr>
-      <p:grpSpPr/>
-      <p:sp>
-        <p:nvSpPr>
-          <p:cNvPr id="2" name="TextBox 1"/>
-          <p:cNvSpPr txBox="1"/>
-          <p:nvPr/>
-        </p:nvSpPr>
-        <p:spPr>
-          <a:xfrm>
-            <a:off x="731520" y="457200"/>
-            <a:ext cx="10728655" cy="1097280"/>
-          </a:xfrm>
-          <a:prstGeom prst="rect">
-            <a:avLst/>
-          </a:prstGeom>
-          <a:noFill/>
-        </p:spPr>
-        <p:txBody>
-          <a:bodyPr wrap="square" lIns="0" tIns="0" rIns="0" bIns="0">
-            <a:spAutoFit/>
-          </a:bodyPr>
-          <a:lstStyle/>
-          <a:p>
-            <a:r>
-              <a:rPr sz="1100" b="1">
-                <a:solidFill>
-                  <a:srgbClr val="0D9488"/>
-                </a:solidFill>
-              </a:rPr>
-              <a:t>CA2 - ACTIVITY 13: DESIGN FOR THE UNSEEN</a:t>
-            </a:r>
-          </a:p>
-          <a:p>
-            <a:r>
-              <a:rPr sz="2600" b="1">
-                <a:solidFill>
-                  <a:srgbClr val="0F172A"/>
-                </a:solidFill>
-              </a:rPr>
-              <a:t>5. We Built Prototype 1: Initial Fast Interactive Build</a:t>
-            </a:r>
-          </a:p>
-        </p:txBody>
-      </p:sp>
-      <p:sp>
-        <p:nvSpPr>
-          <p:cNvPr id="3" name="Rounded Rectangle 2"/>
-          <p:cNvSpPr/>
-          <p:nvPr/>
-        </p:nvSpPr>
-        <p:spPr>
-          <a:xfrm>
-            <a:off x="1371600" y="1828800"/>
-            <a:ext cx="9418320" cy="4389120"/>
-          </a:xfrm>
-          <a:prstGeom prst="roundRect">
-            <a:avLst/>
-          </a:prstGeom>
-          <a:solidFill>
-            <a:srgbClr val="F8FAFC"/>
+            <a:srgbClr val="FFFFFF"/>
           </a:solidFill>
           <a:ln>
             <a:solidFill>
@@ -4533,93 +3422,1884 @@
           </a:fontRef>
         </p:style>
         <p:txBody>
+          <a:bodyPr rtlCol="0" anchor="ctr" wrap="square" lIns="365760" rIns="365760" tIns="365760"/>
+          <a:lstStyle/>
+          <a:p>
+            <a:pPr algn="ctr">
+              <a:defRPr b="1" sz="1300">
+                <a:solidFill>
+                  <a:srgbClr val="0D9488"/>
+                </a:solidFill>
+              </a:defRPr>
+            </a:pPr>
+            <a:r>
+              <a:t>THE UNSEEN STAKEHOLDERS (8 STUDENTS)</a:t>
+            </a:r>
+          </a:p>
+          <a:p>
+            <a:pPr>
+              <a:spcBef>
+                <a:spcPts val="800"/>
+              </a:spcBef>
+              <a:defRPr sz="1150">
+                <a:solidFill>
+                  <a:srgbClr val="0F172A"/>
+                </a:solidFill>
+              </a:defRPr>
+            </a:pPr>
+            <a:r>
+              <a:t>• The Cohort: Allied health technologists operating mechanical ventilators, anaesthesia workstations, and dialyzers.</a:t>
+            </a:r>
+          </a:p>
+          <a:p>
+            <a:pPr>
+              <a:spcBef>
+                <a:spcPts val="800"/>
+              </a:spcBef>
+              <a:defRPr sz="1150">
+                <a:solidFill>
+                  <a:srgbClr val="0F172A"/>
+                </a:solidFill>
+              </a:defRPr>
+            </a:pPr>
+            <a:r>
+              <a:t>• Why Unseen: Instructors see them attaching circuits and assume mastery. But oral vivas by external examiners cause deep panic.</a:t>
+            </a:r>
+          </a:p>
+          <a:p>
+            <a:pPr>
+              <a:spcBef>
+                <a:spcPts val="800"/>
+              </a:spcBef>
+              <a:defRPr sz="1150">
+                <a:solidFill>
+                  <a:srgbClr val="0F172A"/>
+                </a:solidFill>
+              </a:defRPr>
+            </a:pPr>
+            <a:r>
+              <a:t>• Direct Research Participants: Riddhi, Siddhi, Naziya, Preethi, Bhargav, Naveen, Tharun, and Atharv.</a:t>
+            </a:r>
+          </a:p>
+          <a:p>
+            <a:pPr>
+              <a:spcBef>
+                <a:spcPts val="800"/>
+              </a:spcBef>
+              <a:defRPr sz="1150">
+                <a:solidFill>
+                  <a:srgbClr val="0F172A"/>
+                </a:solidFill>
+              </a:defRPr>
+            </a:pPr>
+            <a:r>
+              <a:t>• Observation Grounding: Shadowed 6 clinical shifts across adult ICUs, emergency OTs, and hemodialysis suites.</a:t>
+            </a:r>
+          </a:p>
+        </p:txBody>
+      </p:sp>
+    </p:spTree>
+  </p:cSld>
+  <p:clrMapOvr>
+    <a:masterClrMapping/>
+  </p:clrMapOvr>
+</p:sld>
+</file>
+
+<file path=ppt/slides/slide3.xml><?xml version="1.0" encoding="utf-8"?>
+<p:sld xmlns:a="http://schemas.openxmlformats.org/drawingml/2006/main" xmlns:p="http://schemas.openxmlformats.org/presentationml/2006/main" xmlns:r="http://schemas.openxmlformats.org/officeDocument/2006/relationships">
+  <p:cSld>
+    <p:spTree>
+      <p:nvGrpSpPr>
+        <p:cNvPr id="1" name=""/>
+        <p:cNvGrpSpPr/>
+        <p:nvPr/>
+      </p:nvGrpSpPr>
+      <p:grpSpPr/>
+      <p:sp>
+        <p:nvSpPr>
+          <p:cNvPr id="2" name="TextBox 1"/>
+          <p:cNvSpPr txBox="1"/>
+          <p:nvPr/>
+        </p:nvSpPr>
+        <p:spPr>
+          <a:xfrm>
+            <a:off x="731520" y="365760"/>
+            <a:ext cx="10728655" cy="1005840"/>
+          </a:xfrm>
+          <a:prstGeom prst="rect">
+            <a:avLst/>
+          </a:prstGeom>
+          <a:noFill/>
+        </p:spPr>
+        <p:txBody>
+          <a:bodyPr wrap="square" lIns="0" tIns="0" rIns="0" bIns="0">
+            <a:spAutoFit/>
+          </a:bodyPr>
+          <a:lstStyle/>
+          <a:p>
+            <a:r>
+              <a:rPr sz="1000" b="1">
+                <a:solidFill>
+                  <a:srgbClr val="0D9488"/>
+                </a:solidFill>
+              </a:rPr>
+              <a:t>CA2 - ACTIVITY 13: DESIGN FOR THE UNSEEN</a:t>
+            </a:r>
+          </a:p>
+          <a:p>
+            <a:r>
+              <a:rPr sz="2400" b="1">
+                <a:solidFill>
+                  <a:srgbClr val="0F172A"/>
+                </a:solidFill>
+              </a:rPr>
+              <a:t>2. We Observed &amp; Discovered... (25 Real Clinical Problems)</a:t>
+            </a:r>
+          </a:p>
+        </p:txBody>
+      </p:sp>
+      <p:sp>
+        <p:nvSpPr>
+          <p:cNvPr id="3" name="Rounded Rectangle 2"/>
+          <p:cNvSpPr/>
+          <p:nvPr/>
+        </p:nvSpPr>
+        <p:spPr>
+          <a:xfrm>
+            <a:off x="731520" y="1645920"/>
+            <a:ext cx="2514600" cy="4572000"/>
+          </a:xfrm>
+          <a:prstGeom prst="roundRect">
+            <a:avLst/>
+          </a:prstGeom>
+          <a:solidFill>
+            <a:srgbClr val="FFFFFF"/>
+          </a:solidFill>
+          <a:ln>
+            <a:solidFill>
+              <a:srgbClr val="E2E8F0"/>
+            </a:solidFill>
+          </a:ln>
+        </p:spPr>
+        <p:style>
+          <a:lnRef idx="1">
+            <a:schemeClr val="accent1"/>
+          </a:lnRef>
+          <a:fillRef idx="3">
+            <a:schemeClr val="accent1"/>
+          </a:fillRef>
+          <a:effectRef idx="2">
+            <a:schemeClr val="accent1"/>
+          </a:effectRef>
+          <a:fontRef idx="minor">
+            <a:schemeClr val="lt1"/>
+          </a:fontRef>
+        </p:style>
+        <p:txBody>
+          <a:bodyPr rtlCol="0" anchor="ctr" wrap="square" lIns="228600" rIns="228600" tIns="228600"/>
+          <a:lstStyle/>
+          <a:p>
+            <a:pPr algn="ctr">
+              <a:defRPr b="1" sz="1100">
+                <a:solidFill>
+                  <a:srgbClr val="0284C7"/>
+                </a:solidFill>
+              </a:defRPr>
+            </a:pPr>
+            <a:r>
+              <a:t>A. Airway &amp; Circuit Hazards</a:t>
+            </a:r>
+          </a:p>
+          <a:p>
+            <a:pPr>
+              <a:spcBef>
+                <a:spcPts val="400"/>
+              </a:spcBef>
+              <a:defRPr sz="900">
+                <a:solidFill>
+                  <a:srgbClr val="0F172A"/>
+                </a:solidFill>
+              </a:defRPr>
+            </a:pPr>
+            <a:r>
+              <a:t>• Low water levels in oxygen humidifier bottles (inspissated secretions)</a:t>
+            </a:r>
+          </a:p>
+          <a:p>
+            <a:pPr>
+              <a:spcBef>
+                <a:spcPts val="400"/>
+              </a:spcBef>
+              <a:defRPr sz="900">
+                <a:solidFill>
+                  <a:srgbClr val="0F172A"/>
+                </a:solidFill>
+              </a:defRPr>
+            </a:pPr>
+            <a:r>
+              <a:t>• Accidental patient self-extubation during nurse turns</a:t>
+            </a:r>
+          </a:p>
+          <a:p>
+            <a:pPr>
+              <a:spcBef>
+                <a:spcPts val="400"/>
+              </a:spcBef>
+              <a:defRPr sz="900">
+                <a:solidFill>
+                  <a:srgbClr val="0F172A"/>
+                </a:solidFill>
+              </a:defRPr>
+            </a:pPr>
+            <a:r>
+              <a:t>• Ventilator circuit disconnection during repositioning</a:t>
+            </a:r>
+          </a:p>
+          <a:p>
+            <a:pPr>
+              <a:spcBef>
+                <a:spcPts val="400"/>
+              </a:spcBef>
+              <a:defRPr sz="900">
+                <a:solidFill>
+                  <a:srgbClr val="0F172A"/>
+                </a:solidFill>
+              </a:defRPr>
+            </a:pPr>
+            <a:r>
+              <a:t>• Undetected NIV mask leaks compromising ventilation</a:t>
+            </a:r>
+          </a:p>
+          <a:p>
+            <a:pPr>
+              <a:spcBef>
+                <a:spcPts val="400"/>
+              </a:spcBef>
+              <a:defRPr sz="900">
+                <a:solidFill>
+                  <a:srgbClr val="0F172A"/>
+                </a:solidFill>
+              </a:defRPr>
+            </a:pPr>
+            <a:r>
+              <a:t>• Endotracheal tube (ETT) depth migration past incisors</a:t>
+            </a:r>
+          </a:p>
+          <a:p>
+            <a:pPr>
+              <a:spcBef>
+                <a:spcPts val="400"/>
+              </a:spcBef>
+              <a:defRPr sz="900">
+                <a:solidFill>
+                  <a:srgbClr val="0F172A"/>
+                </a:solidFill>
+              </a:defRPr>
+            </a:pPr>
+            <a:r>
+              <a:t>• Delayed suctioning causing secretion plugging</a:t>
+            </a:r>
+          </a:p>
+        </p:txBody>
+      </p:sp>
+      <p:sp>
+        <p:nvSpPr>
+          <p:cNvPr id="4" name="Rounded Rectangle 3"/>
+          <p:cNvSpPr/>
+          <p:nvPr/>
+        </p:nvSpPr>
+        <p:spPr>
+          <a:xfrm>
+            <a:off x="3429000" y="1645920"/>
+            <a:ext cx="2514600" cy="4572000"/>
+          </a:xfrm>
+          <a:prstGeom prst="roundRect">
+            <a:avLst/>
+          </a:prstGeom>
+          <a:solidFill>
+            <a:srgbClr val="FFFFFF"/>
+          </a:solidFill>
+          <a:ln>
+            <a:solidFill>
+              <a:srgbClr val="E2E8F0"/>
+            </a:solidFill>
+          </a:ln>
+        </p:spPr>
+        <p:style>
+          <a:lnRef idx="1">
+            <a:schemeClr val="accent1"/>
+          </a:lnRef>
+          <a:fillRef idx="3">
+            <a:schemeClr val="accent1"/>
+          </a:fillRef>
+          <a:effectRef idx="2">
+            <a:schemeClr val="accent1"/>
+          </a:effectRef>
+          <a:fontRef idx="minor">
+            <a:schemeClr val="lt1"/>
+          </a:fontRef>
+        </p:style>
+        <p:txBody>
+          <a:bodyPr rtlCol="0" anchor="ctr" wrap="square" lIns="228600" rIns="228600" tIns="228600"/>
+          <a:lstStyle/>
+          <a:p>
+            <a:pPr algn="ctr">
+              <a:defRPr b="1" sz="1100">
+                <a:solidFill>
+                  <a:srgbClr val="0284C7"/>
+                </a:solidFill>
+              </a:defRPr>
+            </a:pPr>
+            <a:r>
+              <a:t>B. Alarms &amp; Critical Events</a:t>
+            </a:r>
+          </a:p>
+          <a:p>
+            <a:pPr>
+              <a:spcBef>
+                <a:spcPts val="400"/>
+              </a:spcBef>
+              <a:defRPr sz="900">
+                <a:solidFill>
+                  <a:srgbClr val="0F172A"/>
+                </a:solidFill>
+              </a:defRPr>
+            </a:pPr>
+            <a:r>
+              <a:t>• Delayed response to high-priority ventilator alarms</a:t>
+            </a:r>
+          </a:p>
+          <a:p>
+            <a:pPr>
+              <a:spcBef>
+                <a:spcPts val="400"/>
+              </a:spcBef>
+              <a:defRPr sz="900">
+                <a:solidFill>
+                  <a:srgbClr val="0F172A"/>
+                </a:solidFill>
+              </a:defRPr>
+            </a:pPr>
+            <a:r>
+              <a:t>• Severe ICU Alarm Fatigue (reflexive muting)</a:t>
+            </a:r>
+          </a:p>
+          <a:p>
+            <a:pPr>
+              <a:spcBef>
+                <a:spcPts val="400"/>
+              </a:spcBef>
+              <a:defRPr sz="900">
+                <a:solidFill>
+                  <a:srgbClr val="0F172A"/>
+                </a:solidFill>
+              </a:defRPr>
+            </a:pPr>
+            <a:r>
+              <a:t>• Unidentified patient-ventilator asynchrony (double triggering)</a:t>
+            </a:r>
+          </a:p>
+          <a:p>
+            <a:pPr>
+              <a:spcBef>
+                <a:spcPts val="400"/>
+              </a:spcBef>
+              <a:defRPr sz="900">
+                <a:solidFill>
+                  <a:srgbClr val="0F172A"/>
+                </a:solidFill>
+              </a:defRPr>
+            </a:pPr>
+            <a:r>
+              <a:t>• Dialyzer TMP spikes &amp; fiber membrane clotting</a:t>
+            </a:r>
+          </a:p>
+          <a:p>
+            <a:pPr>
+              <a:spcBef>
+                <a:spcPts val="400"/>
+              </a:spcBef>
+              <a:defRPr sz="900">
+                <a:solidFill>
+                  <a:srgbClr val="0F172A"/>
+                </a:solidFill>
+              </a:defRPr>
+            </a:pPr>
+            <a:r>
+              <a:t>• Delayed recognition of patient respiratory deterioration</a:t>
+            </a:r>
+          </a:p>
+          <a:p>
+            <a:pPr>
+              <a:spcBef>
+                <a:spcPts val="400"/>
+              </a:spcBef>
+              <a:defRPr sz="900">
+                <a:solidFill>
+                  <a:srgbClr val="0F172A"/>
+                </a:solidFill>
+              </a:defRPr>
+            </a:pPr>
+            <a:r>
+              <a:t>• Repeated unmonitored desaturation episodes</a:t>
+            </a:r>
+          </a:p>
+        </p:txBody>
+      </p:sp>
+      <p:sp>
+        <p:nvSpPr>
+          <p:cNvPr id="5" name="Rounded Rectangle 4"/>
+          <p:cNvSpPr/>
+          <p:nvPr/>
+        </p:nvSpPr>
+        <p:spPr>
+          <a:xfrm>
+            <a:off x="6126480" y="1645920"/>
+            <a:ext cx="2514600" cy="4572000"/>
+          </a:xfrm>
+          <a:prstGeom prst="roundRect">
+            <a:avLst/>
+          </a:prstGeom>
+          <a:solidFill>
+            <a:srgbClr val="FFFFFF"/>
+          </a:solidFill>
+          <a:ln>
+            <a:solidFill>
+              <a:srgbClr val="E2E8F0"/>
+            </a:solidFill>
+          </a:ln>
+        </p:spPr>
+        <p:style>
+          <a:lnRef idx="1">
+            <a:schemeClr val="accent1"/>
+          </a:lnRef>
+          <a:fillRef idx="3">
+            <a:schemeClr val="accent1"/>
+          </a:fillRef>
+          <a:effectRef idx="2">
+            <a:schemeClr val="accent1"/>
+          </a:effectRef>
+          <a:fontRef idx="minor">
+            <a:schemeClr val="lt1"/>
+          </a:fontRef>
+        </p:style>
+        <p:txBody>
+          <a:bodyPr rtlCol="0" anchor="ctr" wrap="square" lIns="228600" rIns="228600" tIns="228600"/>
+          <a:lstStyle/>
+          <a:p>
+            <a:pPr algn="ctr">
+              <a:defRPr b="1" sz="1100">
+                <a:solidFill>
+                  <a:srgbClr val="0284C7"/>
+                </a:solidFill>
+              </a:defRPr>
+            </a:pPr>
+            <a:r>
+              <a:t>C. Ward Workflow &amp; Transport</a:t>
+            </a:r>
+          </a:p>
+          <a:p>
+            <a:pPr>
+              <a:spcBef>
+                <a:spcPts val="400"/>
+              </a:spcBef>
+              <a:defRPr sz="900">
+                <a:solidFill>
+                  <a:srgbClr val="0F172A"/>
+                </a:solidFill>
+              </a:defRPr>
+            </a:pPr>
+            <a:r>
+              <a:t>• Incomplete respiratory therapist shift handovers</a:t>
+            </a:r>
+          </a:p>
+          <a:p>
+            <a:pPr>
+              <a:spcBef>
+                <a:spcPts val="400"/>
+              </a:spcBef>
+              <a:defRPr sz="900">
+                <a:solidFill>
+                  <a:srgbClr val="0F172A"/>
+                </a:solidFill>
+              </a:defRPr>
+            </a:pPr>
+            <a:r>
+              <a:t>• Time-consuming manual paper flowsheet charting</a:t>
+            </a:r>
+          </a:p>
+          <a:p>
+            <a:pPr>
+              <a:spcBef>
+                <a:spcPts val="400"/>
+              </a:spcBef>
+              <a:defRPr sz="900">
+                <a:solidFill>
+                  <a:srgbClr val="0F172A"/>
+                </a:solidFill>
+              </a:defRPr>
+            </a:pPr>
+            <a:r>
+              <a:t>• Transport oxygen cylinder pressure depletion</a:t>
+            </a:r>
+          </a:p>
+          <a:p>
+            <a:pPr>
+              <a:spcBef>
+                <a:spcPts val="400"/>
+              </a:spcBef>
+              <a:defRPr sz="900">
+                <a:solidFill>
+                  <a:srgbClr val="0F172A"/>
+                </a:solidFill>
+              </a:defRPr>
+            </a:pPr>
+            <a:r>
+              <a:t>• Equipment unavailability during emergency code calls</a:t>
+            </a:r>
+          </a:p>
+          <a:p>
+            <a:pPr>
+              <a:spcBef>
+                <a:spcPts val="400"/>
+              </a:spcBef>
+              <a:defRPr sz="900">
+                <a:solidFill>
+                  <a:srgbClr val="0F172A"/>
+                </a:solidFill>
+              </a:defRPr>
+            </a:pPr>
+            <a:r>
+              <a:t>• Missing/lost chest X-ray jackets during morning rounds</a:t>
+            </a:r>
+          </a:p>
+          <a:p>
+            <a:pPr>
+              <a:spcBef>
+                <a:spcPts val="400"/>
+              </a:spcBef>
+              <a:defRPr sz="900">
+                <a:solidFill>
+                  <a:srgbClr val="0F172A"/>
+                </a:solidFill>
+              </a:defRPr>
+            </a:pPr>
+            <a:r>
+              <a:t>• Expired equipment maintenance &amp; sensor calibrations</a:t>
+            </a:r>
+          </a:p>
+        </p:txBody>
+      </p:sp>
+      <p:sp>
+        <p:nvSpPr>
+          <p:cNvPr id="6" name="Rounded Rectangle 5"/>
+          <p:cNvSpPr/>
+          <p:nvPr/>
+        </p:nvSpPr>
+        <p:spPr>
+          <a:xfrm>
+            <a:off x="8823960" y="1645920"/>
+            <a:ext cx="2514600" cy="4572000"/>
+          </a:xfrm>
+          <a:prstGeom prst="roundRect">
+            <a:avLst/>
+          </a:prstGeom>
+          <a:solidFill>
+            <a:srgbClr val="FFFFFF"/>
+          </a:solidFill>
+          <a:ln>
+            <a:solidFill>
+              <a:srgbClr val="E2E8F0"/>
+            </a:solidFill>
+          </a:ln>
+        </p:spPr>
+        <p:style>
+          <a:lnRef idx="1">
+            <a:schemeClr val="accent1"/>
+          </a:lnRef>
+          <a:fillRef idx="3">
+            <a:schemeClr val="accent1"/>
+          </a:fillRef>
+          <a:effectRef idx="2">
+            <a:schemeClr val="accent1"/>
+          </a:effectRef>
+          <a:fontRef idx="minor">
+            <a:schemeClr val="lt1"/>
+          </a:fontRef>
+        </p:style>
+        <p:txBody>
+          <a:bodyPr rtlCol="0" anchor="ctr" wrap="square" lIns="228600" rIns="228600" tIns="228600"/>
+          <a:lstStyle/>
+          <a:p>
+            <a:pPr algn="ctr">
+              <a:defRPr b="1" sz="1100">
+                <a:solidFill>
+                  <a:srgbClr val="0284C7"/>
+                </a:solidFill>
+              </a:defRPr>
+            </a:pPr>
+            <a:r>
+              <a:t>D. Data Overload &amp; Reasoning</a:t>
+            </a:r>
+          </a:p>
+          <a:p>
+            <a:pPr>
+              <a:spcBef>
+                <a:spcPts val="400"/>
+              </a:spcBef>
+              <a:defRPr sz="900">
+                <a:solidFill>
+                  <a:srgbClr val="0F172A"/>
+                </a:solidFill>
+              </a:defRPr>
+            </a:pPr>
+            <a:r>
+              <a:t>• Difficulty correlating real-time ABG reports with vent changes</a:t>
+            </a:r>
+          </a:p>
+          <a:p>
+            <a:pPr>
+              <a:spcBef>
+                <a:spcPts val="400"/>
+              </a:spcBef>
+              <a:defRPr sz="900">
+                <a:solidFill>
+                  <a:srgbClr val="0F172A"/>
+                </a:solidFill>
+              </a:defRPr>
+            </a:pPr>
+            <a:r>
+              <a:t>• Missed spontaneous breathing trials (SBT) for weaning</a:t>
+            </a:r>
+          </a:p>
+          <a:p>
+            <a:pPr>
+              <a:spcBef>
+                <a:spcPts val="400"/>
+              </a:spcBef>
+              <a:defRPr sz="900">
+                <a:solidFill>
+                  <a:srgbClr val="0F172A"/>
+                </a:solidFill>
+              </a:defRPr>
+            </a:pPr>
+            <a:r>
+              <a:t>• Inadequate monitoring of delivered FiO2 &amp; flow rates</a:t>
+            </a:r>
+          </a:p>
+          <a:p>
+            <a:pPr>
+              <a:spcBef>
+                <a:spcPts val="400"/>
+              </a:spcBef>
+              <a:defRPr sz="900">
+                <a:solidFill>
+                  <a:srgbClr val="0F172A"/>
+                </a:solidFill>
+              </a:defRPr>
+            </a:pPr>
+            <a:r>
+              <a:t>• Managing pending RT orders across 15-20 beds</a:t>
+            </a:r>
+          </a:p>
+          <a:p>
+            <a:pPr>
+              <a:spcBef>
+                <a:spcPts val="400"/>
+              </a:spcBef>
+              <a:defRPr sz="900">
+                <a:solidFill>
+                  <a:srgbClr val="0F172A"/>
+                </a:solidFill>
+              </a:defRPr>
+            </a:pPr>
+            <a:r>
+              <a:t>• Lack of a centralized respiratory monitoring dashboard</a:t>
+            </a:r>
+          </a:p>
+        </p:txBody>
+      </p:sp>
+    </p:spTree>
+  </p:cSld>
+  <p:clrMapOvr>
+    <a:masterClrMapping/>
+  </p:clrMapOvr>
+</p:sld>
+</file>
+
+<file path=ppt/slides/slide4.xml><?xml version="1.0" encoding="utf-8"?>
+<p:sld xmlns:a="http://schemas.openxmlformats.org/drawingml/2006/main" xmlns:p="http://schemas.openxmlformats.org/presentationml/2006/main" xmlns:r="http://schemas.openxmlformats.org/officeDocument/2006/relationships">
+  <p:cSld>
+    <p:spTree>
+      <p:nvGrpSpPr>
+        <p:cNvPr id="1" name=""/>
+        <p:cNvGrpSpPr/>
+        <p:nvPr/>
+      </p:nvGrpSpPr>
+      <p:grpSpPr/>
+      <p:sp>
+        <p:nvSpPr>
+          <p:cNvPr id="2" name="TextBox 1"/>
+          <p:cNvSpPr txBox="1"/>
+          <p:nvPr/>
+        </p:nvSpPr>
+        <p:spPr>
+          <a:xfrm>
+            <a:off x="731520" y="365760"/>
+            <a:ext cx="10728655" cy="1005840"/>
+          </a:xfrm>
+          <a:prstGeom prst="rect">
+            <a:avLst/>
+          </a:prstGeom>
+          <a:noFill/>
+        </p:spPr>
+        <p:txBody>
+          <a:bodyPr wrap="square" lIns="0" tIns="0" rIns="0" bIns="0">
+            <a:spAutoFit/>
+          </a:bodyPr>
+          <a:lstStyle/>
+          <a:p>
+            <a:r>
+              <a:rPr sz="1000" b="1">
+                <a:solidFill>
+                  <a:srgbClr val="0D9488"/>
+                </a:solidFill>
+              </a:rPr>
+              <a:t>CA2 - ACTIVITY 13: DESIGN FOR THE UNSEEN</a:t>
+            </a:r>
+          </a:p>
+          <a:p>
+            <a:r>
+              <a:rPr sz="2400" b="1">
+                <a:solidFill>
+                  <a:srgbClr val="0F172A"/>
+                </a:solidFill>
+              </a:rPr>
+              <a:t>3. We Realised the Real Problem Was: Passive Revision Syndrome</a:t>
+            </a:r>
+          </a:p>
+        </p:txBody>
+      </p:sp>
+      <p:sp>
+        <p:nvSpPr>
+          <p:cNvPr id="3" name="Rounded Rectangle 2"/>
+          <p:cNvSpPr/>
+          <p:nvPr/>
+        </p:nvSpPr>
+        <p:spPr>
+          <a:xfrm>
+            <a:off x="731520" y="1645920"/>
+            <a:ext cx="10728655" cy="4572000"/>
+          </a:xfrm>
+          <a:prstGeom prst="roundRect">
+            <a:avLst/>
+          </a:prstGeom>
+          <a:solidFill>
+            <a:srgbClr val="FFFFFF"/>
+          </a:solidFill>
+          <a:ln>
+            <a:solidFill>
+              <a:srgbClr val="E2E8F0"/>
+            </a:solidFill>
+          </a:ln>
+        </p:spPr>
+        <p:style>
+          <a:lnRef idx="1">
+            <a:schemeClr val="accent1"/>
+          </a:lnRef>
+          <a:fillRef idx="3">
+            <a:schemeClr val="accent1"/>
+          </a:fillRef>
+          <a:effectRef idx="2">
+            <a:schemeClr val="accent1"/>
+          </a:effectRef>
+          <a:fontRef idx="minor">
+            <a:schemeClr val="lt1"/>
+          </a:fontRef>
+        </p:style>
+        <p:txBody>
           <a:bodyPr rtlCol="0" anchor="ctr" wrap="square" lIns="457200" rIns="457200" tIns="457200"/>
           <a:lstStyle/>
           <a:p>
             <a:pPr algn="ctr">
-              <a:defRPr b="1" sz="1400">
-                <a:solidFill>
-                  <a:srgbClr val="0284C7"/>
-                </a:solidFill>
-              </a:defRPr>
-            </a:pPr>
-            <a:r>
-              <a:t>PROTOTYPE 1 ARCHITECTURE &amp; CAPABILITIES</a:t>
+              <a:defRPr b="1" sz="1300">
+                <a:solidFill>
+                  <a:srgbClr val="0D9488"/>
+                </a:solidFill>
+              </a:defRPr>
+            </a:pPr>
+            <a:r>
+              <a:t>THE ROOT CAUSE DISCOVERED BEHIND ALL 25 PROBLEMS:</a:t>
             </a:r>
           </a:p>
           <a:p>
             <a:pPr>
               <a:spcBef>
-                <a:spcPts val="1200"/>
+                <a:spcPts val="1000"/>
               </a:spcBef>
-              <a:defRPr sz="1250">
+              <a:defRPr sz="1600" b="1">
                 <a:solidFill>
                   <a:srgbClr val="0F172A"/>
                 </a:solidFill>
               </a:defRPr>
             </a:pPr>
             <a:r>
-              <a:t>• Rapid Python + Streamlit Web Implementation: Built as an interactive prototype to test formative practice.</a:t>
+              <a:t>"Students know what button to press, but freeze completely when external examiners ask WHY a ventilator pressure spiked or HOW an APL valve functions."</a:t>
             </a:r>
           </a:p>
           <a:p>
             <a:pPr>
               <a:spcBef>
-                <a:spcPts val="1200"/>
+                <a:spcPts val="600"/>
               </a:spcBef>
-              <a:defRPr sz="1250">
+              <a:defRPr sz="1100">
                 <a:solidFill>
                   <a:srgbClr val="0F172A"/>
                 </a:solidFill>
               </a:defRPr>
             </a:pPr>
             <a:r>
-              <a:t>• 24 Curated Practical Questions: 8 questions per specialty across Respiratory, Anaesthesia, and Dialysis technology.</a:t>
+              <a:t>• Passive Revision Syndrome: Reading PDFs, notes, and manuals creates an illusion of competence. Passive reading does not activate active recall circuits.</a:t>
             </a:r>
           </a:p>
           <a:p>
             <a:pPr>
               <a:spcBef>
-                <a:spcPts val="1200"/>
+                <a:spcPts val="600"/>
               </a:spcBef>
-              <a:defRPr sz="1250">
+              <a:defRPr sz="1100">
                 <a:solidFill>
                   <a:srgbClr val="0F172A"/>
                 </a:solidFill>
               </a:defRPr>
             </a:pPr>
             <a:r>
-              <a:t>• Basic MCQ Mechanics: 4-option radio selection with synchronous Check Answer feedback.</a:t>
+              <a:t>• Oral Viva Reality: Examiners do not give 4 multiple-choice options; they ask rapid oral questions under severe time pressure.</a:t>
             </a:r>
           </a:p>
           <a:p>
             <a:pPr>
               <a:spcBef>
-                <a:spcPts val="1200"/>
+                <a:spcPts val="600"/>
               </a:spcBef>
-              <a:defRPr sz="1250">
+              <a:defRPr sz="1100">
                 <a:solidFill>
                   <a:srgbClr val="0F172A"/>
                 </a:solidFill>
               </a:defRPr>
             </a:pPr>
             <a:r>
-              <a:t>• Basic Score Metrics: Tracking attempted questions, correct count, and live session accuracy.</a:t>
+              <a:t>• Fear of Judgment: Mock vivas with seniors or professors induce fear. Students need a safe, zero-judgment digital sandbox.</a:t>
             </a:r>
           </a:p>
           <a:p>
             <a:pPr>
               <a:spcBef>
-                <a:spcPts val="1200"/>
+                <a:spcPts val="600"/>
               </a:spcBef>
-              <a:defRPr sz="1250">
+              <a:defRPr sz="1100">
                 <a:solidFill>
                   <a:srgbClr val="0F172A"/>
                 </a:solidFill>
               </a:defRPr>
             </a:pPr>
             <a:r>
-              <a:t>• Initial Limitation Identified: Lacked oral self-testing; small question bank; broke if external API key was missing; had critical mobile dark-mode contrast defect.</a:t>
+              <a:t>• The Missing Bridge: No educational tool existed that bridged routine hospital procedures with verbal physiological reasoning.</a:t>
+            </a:r>
+          </a:p>
+          <a:p>
+            <a:pPr>
+              <a:spcBef>
+                <a:spcPts val="600"/>
+              </a:spcBef>
+              <a:defRPr sz="1100">
+                <a:solidFill>
+                  <a:srgbClr val="0F172A"/>
+                </a:solidFill>
+              </a:defRPr>
+            </a:pPr>
+            <a:r>
+              <a:t>• Reframed Problem Statement: How might we provide healthcare technology students with an accessible, interactive digital viva simulator that pinpoints conceptual misconceptions and provides verified textbook explanations without requiring complex infrastructure?</a:t>
+            </a:r>
+          </a:p>
+        </p:txBody>
+      </p:sp>
+    </p:spTree>
+  </p:cSld>
+  <p:clrMapOvr>
+    <a:masterClrMapping/>
+  </p:clrMapOvr>
+</p:sld>
+</file>
+
+<file path=ppt/slides/slide5.xml><?xml version="1.0" encoding="utf-8"?>
+<p:sld xmlns:a="http://schemas.openxmlformats.org/drawingml/2006/main" xmlns:p="http://schemas.openxmlformats.org/presentationml/2006/main" xmlns:r="http://schemas.openxmlformats.org/officeDocument/2006/relationships">
+  <p:cSld>
+    <p:spTree>
+      <p:nvGrpSpPr>
+        <p:cNvPr id="1" name=""/>
+        <p:cNvGrpSpPr/>
+        <p:nvPr/>
+      </p:nvGrpSpPr>
+      <p:grpSpPr/>
+      <p:sp>
+        <p:nvSpPr>
+          <p:cNvPr id="2" name="TextBox 1"/>
+          <p:cNvSpPr txBox="1"/>
+          <p:nvPr/>
+        </p:nvSpPr>
+        <p:spPr>
+          <a:xfrm>
+            <a:off x="731520" y="365760"/>
+            <a:ext cx="10728655" cy="1005840"/>
+          </a:xfrm>
+          <a:prstGeom prst="rect">
+            <a:avLst/>
+          </a:prstGeom>
+          <a:noFill/>
+        </p:spPr>
+        <p:txBody>
+          <a:bodyPr wrap="square" lIns="0" tIns="0" rIns="0" bIns="0">
+            <a:spAutoFit/>
+          </a:bodyPr>
+          <a:lstStyle/>
+          <a:p>
+            <a:r>
+              <a:rPr sz="1000" b="1">
+                <a:solidFill>
+                  <a:srgbClr val="0D9488"/>
+                </a:solidFill>
+              </a:rPr>
+              <a:t>CA2 - ACTIVITY 13: DESIGN FOR THE UNSEEN</a:t>
+            </a:r>
+          </a:p>
+          <a:p>
+            <a:r>
+              <a:rPr sz="2400" b="1">
+                <a:solidFill>
+                  <a:srgbClr val="0F172A"/>
+                </a:solidFill>
+              </a:rPr>
+              <a:t>4. What Makes MedSkill AI Different From a Generic AI Chatbot?</a:t>
+            </a:r>
+          </a:p>
+        </p:txBody>
+      </p:sp>
+      <p:graphicFrame>
+        <p:nvGraphicFramePr>
+          <p:cNvPr id="3" name="Table 2"/>
+          <p:cNvGraphicFramePr>
+            <a:graphicFrameLocks noGrp="1"/>
+          </p:cNvGraphicFramePr>
+          <p:nvPr/>
+        </p:nvGraphicFramePr>
+        <p:xfrm>
+          <a:off x="731520" y="1645920"/>
+          <a:ext cx="10728655" cy="4572000"/>
+        </p:xfrm>
+        <a:graphic>
+          <a:graphicData uri="http://schemas.openxmlformats.org/drawingml/2006/table">
+            <a:tbl>
+              <a:tblPr firstRow="1" bandRow="1">
+                <a:tableStyleId>{5C22544A-7EE6-4342-B048-85BDC9FD1C3A}</a:tableStyleId>
+              </a:tblPr>
+              <a:tblGrid>
+                <a:gridCol w="2286000"/>
+                <a:gridCol w="4114800"/>
+                <a:gridCol w="4327855"/>
+              </a:tblGrid>
+              <a:tr h="653142">
+                <a:tc>
+                  <a:txBody>
+                    <a:bodyPr/>
+                    <a:lstStyle/>
+                    <a:p>
+                      <a:pPr>
+                        <a:defRPr b="1" sz="1100">
+                          <a:solidFill>
+                            <a:srgbClr val="FFFFFF"/>
+                          </a:solidFill>
+                        </a:defRPr>
+                      </a:pPr>
+                      <a:r>
+                        <a:t>Evaluation Dimension</a:t>
+                      </a:r>
+                    </a:p>
+                  </a:txBody>
+                  <a:tcPr>
+                    <a:solidFill>
+                      <a:srgbClr val="0F172A"/>
+                    </a:solidFill>
+                  </a:tcPr>
+                </a:tc>
+                <a:tc>
+                  <a:txBody>
+                    <a:bodyPr/>
+                    <a:lstStyle/>
+                    <a:p>
+                      <a:pPr>
+                        <a:defRPr b="1" sz="1100">
+                          <a:solidFill>
+                            <a:srgbClr val="FFFFFF"/>
+                          </a:solidFill>
+                        </a:defRPr>
+                      </a:pPr>
+                      <a:r>
+                        <a:t>Generic AI Chatbot (ChatGPT / Claude / Copilot)</a:t>
+                      </a:r>
+                    </a:p>
+                  </a:txBody>
+                  <a:tcPr>
+                    <a:solidFill>
+                      <a:srgbClr val="0F172A"/>
+                    </a:solidFill>
+                  </a:tcPr>
+                </a:tc>
+                <a:tc>
+                  <a:txBody>
+                    <a:bodyPr/>
+                    <a:lstStyle/>
+                    <a:p>
+                      <a:pPr>
+                        <a:defRPr b="1" sz="1100">
+                          <a:solidFill>
+                            <a:srgbClr val="FFFFFF"/>
+                          </a:solidFill>
+                        </a:defRPr>
+                      </a:pPr>
+                      <a:r>
+                        <a:t>MedSkill AI (Dedicated Viva Simulator)</a:t>
+                      </a:r>
+                    </a:p>
+                  </a:txBody>
+                  <a:tcPr>
+                    <a:solidFill>
+                      <a:srgbClr val="0F172A"/>
+                    </a:solidFill>
+                  </a:tcPr>
+                </a:tc>
+              </a:tr>
+              <a:tr h="653142">
+                <a:tc>
+                  <a:txBody>
+                    <a:bodyPr/>
+                    <a:lstStyle/>
+                    <a:p>
+                      <a:pPr>
+                        <a:defRPr sz="950">
+                          <a:solidFill>
+                            <a:srgbClr val="0F172A"/>
+                          </a:solidFill>
+                        </a:defRPr>
+                      </a:pPr>
+                      <a:r>
+                        <a:t>Curriculum Grounding</a:t>
+                      </a:r>
+                    </a:p>
+                  </a:txBody>
+                  <a:tcPr>
+                    <a:solidFill>
+                      <a:srgbClr val="F8FAFC"/>
+                    </a:solidFill>
+                  </a:tcPr>
+                </a:tc>
+                <a:tc>
+                  <a:txBody>
+                    <a:bodyPr/>
+                    <a:lstStyle/>
+                    <a:p>
+                      <a:pPr>
+                        <a:defRPr sz="950">
+                          <a:solidFill>
+                            <a:srgbClr val="0F172A"/>
+                          </a:solidFill>
+                        </a:defRPr>
+                      </a:pPr>
+                      <a:r>
+                        <a:t>Generic, unpredictable generation; prone to clinical hallucinations &amp; unverified values.</a:t>
+                      </a:r>
+                    </a:p>
+                  </a:txBody>
+                  <a:tcPr>
+                    <a:solidFill>
+                      <a:srgbClr val="F8FAFC"/>
+                    </a:solidFill>
+                  </a:tcPr>
+                </a:tc>
+                <a:tc>
+                  <a:txBody>
+                    <a:bodyPr/>
+                    <a:lstStyle/>
+                    <a:p>
+                      <a:pPr>
+                        <a:defRPr sz="950">
+                          <a:solidFill>
+                            <a:srgbClr val="0F172A"/>
+                          </a:solidFill>
+                        </a:defRPr>
+                      </a:pPr>
+                      <a:r>
+                        <a:t>144 verified curriculum questions anchored in Egan, Miller, and Daugirdas textbooks.</a:t>
+                      </a:r>
+                    </a:p>
+                  </a:txBody>
+                  <a:tcPr>
+                    <a:solidFill>
+                      <a:srgbClr val="F0FDF4"/>
+                    </a:solidFill>
+                  </a:tcPr>
+                </a:tc>
+              </a:tr>
+              <a:tr h="653142">
+                <a:tc>
+                  <a:txBody>
+                    <a:bodyPr/>
+                    <a:lstStyle/>
+                    <a:p>
+                      <a:pPr>
+                        <a:defRPr sz="950">
+                          <a:solidFill>
+                            <a:srgbClr val="0F172A"/>
+                          </a:solidFill>
+                        </a:defRPr>
+                      </a:pPr>
+                      <a:r>
+                        <a:t>Psychological Viva Urgency</a:t>
+                      </a:r>
+                    </a:p>
+                  </a:txBody>
+                  <a:tcPr>
+                    <a:solidFill>
+                      <a:srgbClr val="FFFFFF"/>
+                    </a:solidFill>
+                  </a:tcPr>
+                </a:tc>
+                <a:tc>
+                  <a:txBody>
+                    <a:bodyPr/>
+                    <a:lstStyle/>
+                    <a:p>
+                      <a:pPr>
+                        <a:defRPr sz="950">
+                          <a:solidFill>
+                            <a:srgbClr val="0F172A"/>
+                          </a:solidFill>
+                        </a:defRPr>
+                      </a:pPr>
+                      <a:r>
+                        <a:t>No time pressure. Chatbots sit passively waiting for user text with zero stress stimulus.</a:t>
+                      </a:r>
+                    </a:p>
+                  </a:txBody>
+                  <a:tcPr>
+                    <a:solidFill>
+                      <a:srgbClr val="FFFFFF"/>
+                    </a:solidFill>
+                  </a:tcPr>
+                </a:tc>
+                <a:tc>
+                  <a:txBody>
+                    <a:bodyPr/>
+                    <a:lstStyle/>
+                    <a:p>
+                      <a:pPr>
+                        <a:defRPr sz="950">
+                          <a:solidFill>
+                            <a:srgbClr val="0F172A"/>
+                          </a:solidFill>
+                        </a:defRPr>
+                      </a:pPr>
+                      <a:r>
+                        <a:t>30-Second Examiner Pressure Mode: Active countdown timer replicating oral viva anxiety.</a:t>
+                      </a:r>
+                    </a:p>
+                  </a:txBody>
+                  <a:tcPr>
+                    <a:solidFill>
+                      <a:srgbClr val="F0FDFA"/>
+                    </a:solidFill>
+                  </a:tcPr>
+                </a:tc>
+              </a:tr>
+              <a:tr h="653142">
+                <a:tc>
+                  <a:txBody>
+                    <a:bodyPr/>
+                    <a:lstStyle/>
+                    <a:p>
+                      <a:pPr>
+                        <a:defRPr sz="950">
+                          <a:solidFill>
+                            <a:srgbClr val="0F172A"/>
+                          </a:solidFill>
+                        </a:defRPr>
+                      </a:pPr>
+                      <a:r>
+                        <a:t>Offline Reliability</a:t>
+                      </a:r>
+                    </a:p>
+                  </a:txBody>
+                  <a:tcPr>
+                    <a:solidFill>
+                      <a:srgbClr val="F8FAFC"/>
+                    </a:solidFill>
+                  </a:tcPr>
+                </a:tc>
+                <a:tc>
+                  <a:txBody>
+                    <a:bodyPr/>
+                    <a:lstStyle/>
+                    <a:p>
+                      <a:pPr>
+                        <a:defRPr sz="950">
+                          <a:solidFill>
+                            <a:srgbClr val="0F172A"/>
+                          </a:solidFill>
+                        </a:defRPr>
+                      </a:pPr>
+                      <a:r>
+                        <a:t>Requires 100% active cloud connection; completely fails in shielded hospital basements &amp; labs.</a:t>
+                      </a:r>
+                    </a:p>
+                  </a:txBody>
+                  <a:tcPr>
+                    <a:solidFill>
+                      <a:srgbClr val="F8FAFC"/>
+                    </a:solidFill>
+                  </a:tcPr>
+                </a:tc>
+                <a:tc>
+                  <a:txBody>
+                    <a:bodyPr/>
+                    <a:lstStyle/>
+                    <a:p>
+                      <a:pPr>
+                        <a:defRPr sz="950">
+                          <a:solidFill>
+                            <a:srgbClr val="0F172A"/>
+                          </a:solidFill>
+                        </a:defRPr>
+                      </a:pPr>
+                      <a:r>
+                        <a:t>100% Offline-First Architecture: Local keyword retrieval engine runs with zero API keys or network.</a:t>
+                      </a:r>
+                    </a:p>
+                  </a:txBody>
+                  <a:tcPr>
+                    <a:solidFill>
+                      <a:srgbClr val="F0FDF4"/>
+                    </a:solidFill>
+                  </a:tcPr>
+                </a:tc>
+              </a:tr>
+              <a:tr h="653142">
+                <a:tc>
+                  <a:txBody>
+                    <a:bodyPr/>
+                    <a:lstStyle/>
+                    <a:p>
+                      <a:pPr>
+                        <a:defRPr sz="950">
+                          <a:solidFill>
+                            <a:srgbClr val="0F172A"/>
+                          </a:solidFill>
+                        </a:defRPr>
+                      </a:pPr>
+                      <a:r>
+                        <a:t>Structured Practice Flow</a:t>
+                      </a:r>
+                    </a:p>
+                  </a:txBody>
+                  <a:tcPr>
+                    <a:solidFill>
+                      <a:srgbClr val="FFFFFF"/>
+                    </a:solidFill>
+                  </a:tcPr>
+                </a:tc>
+                <a:tc>
+                  <a:txBody>
+                    <a:bodyPr/>
+                    <a:lstStyle/>
+                    <a:p>
+                      <a:pPr>
+                        <a:defRPr sz="950">
+                          <a:solidFill>
+                            <a:srgbClr val="0F172A"/>
+                          </a:solidFill>
+                        </a:defRPr>
+                      </a:pPr>
+                      <a:r>
+                        <a:t>Open-ended chat log with no concept of passing, failing, difficulty tiers, or topics.</a:t>
+                      </a:r>
+                    </a:p>
+                  </a:txBody>
+                  <a:tcPr>
+                    <a:solidFill>
+                      <a:srgbClr val="FFFFFF"/>
+                    </a:solidFill>
+                  </a:tcPr>
+                </a:tc>
+                <a:tc>
+                  <a:txBody>
+                    <a:bodyPr/>
+                    <a:lstStyle/>
+                    <a:p>
+                      <a:pPr>
+                        <a:defRPr sz="950">
+                          <a:solidFill>
+                            <a:srgbClr val="0F172A"/>
+                          </a:solidFill>
+                        </a:defRPr>
+                      </a:pPr>
+                      <a:r>
+                        <a:t>Dual Mode (Objective MCQ + Quick Viva comparison against model instructor answers).</a:t>
+                      </a:r>
+                    </a:p>
+                  </a:txBody>
+                  <a:tcPr>
+                    <a:solidFill>
+                      <a:srgbClr val="F0FDFA"/>
+                    </a:solidFill>
+                  </a:tcPr>
+                </a:tc>
+              </a:tr>
+              <a:tr h="653142">
+                <a:tc>
+                  <a:txBody>
+                    <a:bodyPr/>
+                    <a:lstStyle/>
+                    <a:p>
+                      <a:pPr>
+                        <a:defRPr sz="950">
+                          <a:solidFill>
+                            <a:srgbClr val="0F172A"/>
+                          </a:solidFill>
+                        </a:defRPr>
+                      </a:pPr>
+                      <a:r>
+                        <a:t>Remediation &amp; Takeaways</a:t>
+                      </a:r>
+                    </a:p>
+                  </a:txBody>
+                  <a:tcPr>
+                    <a:solidFill>
+                      <a:srgbClr val="F8FAFC"/>
+                    </a:solidFill>
+                  </a:tcPr>
+                </a:tc>
+                <a:tc>
+                  <a:txBody>
+                    <a:bodyPr/>
+                    <a:lstStyle/>
+                    <a:p>
+                      <a:pPr>
+                        <a:defRPr sz="950">
+                          <a:solidFill>
+                            <a:srgbClr val="0F172A"/>
+                          </a:solidFill>
+                        </a:defRPr>
+                      </a:pPr>
+                      <a:r>
+                        <a:t>No structured gap analysis. Student must prompt 'quiz me on what I got wrong'.</a:t>
+                      </a:r>
+                    </a:p>
+                  </a:txBody>
+                  <a:tcPr>
+                    <a:solidFill>
+                      <a:srgbClr val="F8FAFC"/>
+                    </a:solidFill>
+                  </a:tcPr>
+                </a:tc>
+                <a:tc>
+                  <a:txBody>
+                    <a:bodyPr/>
+                    <a:lstStyle/>
+                    <a:p>
+                      <a:pPr>
+                        <a:defRPr sz="950">
+                          <a:solidFill>
+                            <a:srgbClr val="0F172A"/>
+                          </a:solidFill>
+                        </a:defRPr>
+                      </a:pPr>
+                      <a:r>
+                        <a:t>1-Click Retry Quiz targeting missed items + 1-Click Pocket Viva Cram Sheet (.docx generator).</a:t>
+                      </a:r>
+                    </a:p>
+                  </a:txBody>
+                  <a:tcPr>
+                    <a:solidFill>
+                      <a:srgbClr val="F0FDF4"/>
+                    </a:solidFill>
+                  </a:tcPr>
+                </a:tc>
+              </a:tr>
+              <a:tr h="653148">
+                <a:tc>
+                  <a:txBody>
+                    <a:bodyPr/>
+                    <a:lstStyle/>
+                    <a:p>
+                      <a:pPr>
+                        <a:defRPr sz="950">
+                          <a:solidFill>
+                            <a:srgbClr val="0F172A"/>
+                          </a:solidFill>
+                        </a:defRPr>
+                      </a:pPr>
+                      <a:r>
+                        <a:t>Clinical Safety Boundaries</a:t>
+                      </a:r>
+                    </a:p>
+                  </a:txBody>
+                  <a:tcPr>
+                    <a:solidFill>
+                      <a:srgbClr val="FFFFFF"/>
+                    </a:solidFill>
+                  </a:tcPr>
+                </a:tc>
+                <a:tc>
+                  <a:txBody>
+                    <a:bodyPr/>
+                    <a:lstStyle/>
+                    <a:p>
+                      <a:pPr>
+                        <a:defRPr sz="950">
+                          <a:solidFill>
+                            <a:srgbClr val="0F172A"/>
+                          </a:solidFill>
+                        </a:defRPr>
+                      </a:pPr>
+                      <a:r>
+                        <a:t>Unbounded generative text; may hallucinate dangerous prescribing recommendations.</a:t>
+                      </a:r>
+                    </a:p>
+                  </a:txBody>
+                  <a:tcPr>
+                    <a:solidFill>
+                      <a:srgbClr val="FFFFFF"/>
+                    </a:solidFill>
+                  </a:tcPr>
+                </a:tc>
+                <a:tc>
+                  <a:txBody>
+                    <a:bodyPr/>
+                    <a:lstStyle/>
+                    <a:p>
+                      <a:pPr>
+                        <a:defRPr sz="950">
+                          <a:solidFill>
+                            <a:srgbClr val="0F172A"/>
+                          </a:solidFill>
+                        </a:defRPr>
+                      </a:pPr>
+                      <a:r>
+                        <a:t>Strict educational scope; explicit clinical disclaimer; no diagnostic or clinical liability.</a:t>
+                      </a:r>
+                    </a:p>
+                  </a:txBody>
+                  <a:tcPr>
+                    <a:solidFill>
+                      <a:srgbClr val="F0FDFA"/>
+                    </a:solidFill>
+                  </a:tcPr>
+                </a:tc>
+              </a:tr>
+            </a:tbl>
+          </a:graphicData>
+        </a:graphic>
+      </p:graphicFrame>
+    </p:spTree>
+  </p:cSld>
+  <p:clrMapOvr>
+    <a:masterClrMapping/>
+  </p:clrMapOvr>
+</p:sld>
+</file>
+
+<file path=ppt/slides/slide6.xml><?xml version="1.0" encoding="utf-8"?>
+<p:sld xmlns:a="http://schemas.openxmlformats.org/drawingml/2006/main" xmlns:p="http://schemas.openxmlformats.org/presentationml/2006/main" xmlns:r="http://schemas.openxmlformats.org/officeDocument/2006/relationships">
+  <p:cSld>
+    <p:spTree>
+      <p:nvGrpSpPr>
+        <p:cNvPr id="1" name=""/>
+        <p:cNvGrpSpPr/>
+        <p:nvPr/>
+      </p:nvGrpSpPr>
+      <p:grpSpPr/>
+      <p:sp>
+        <p:nvSpPr>
+          <p:cNvPr id="2" name="TextBox 1"/>
+          <p:cNvSpPr txBox="1"/>
+          <p:nvPr/>
+        </p:nvSpPr>
+        <p:spPr>
+          <a:xfrm>
+            <a:off x="731520" y="365760"/>
+            <a:ext cx="10728655" cy="1005840"/>
+          </a:xfrm>
+          <a:prstGeom prst="rect">
+            <a:avLst/>
+          </a:prstGeom>
+          <a:noFill/>
+        </p:spPr>
+        <p:txBody>
+          <a:bodyPr wrap="square" lIns="0" tIns="0" rIns="0" bIns="0">
+            <a:spAutoFit/>
+          </a:bodyPr>
+          <a:lstStyle/>
+          <a:p>
+            <a:r>
+              <a:rPr sz="1000" b="1">
+                <a:solidFill>
+                  <a:srgbClr val="0D9488"/>
+                </a:solidFill>
+              </a:rPr>
+              <a:t>CA2 - ACTIVITY 13: DESIGN FOR THE UNSEEN</a:t>
+            </a:r>
+          </a:p>
+          <a:p>
+            <a:r>
+              <a:rPr sz="2400" b="1">
+                <a:solidFill>
+                  <a:srgbClr val="0F172A"/>
+                </a:solidFill>
+              </a:rPr>
+              <a:t>5. We Generated &amp; Killed Our First Idea (Concept Selection)</a:t>
+            </a:r>
+          </a:p>
+        </p:txBody>
+      </p:sp>
+      <p:sp>
+        <p:nvSpPr>
+          <p:cNvPr id="3" name="Rounded Rectangle 2"/>
+          <p:cNvSpPr/>
+          <p:nvPr/>
+        </p:nvSpPr>
+        <p:spPr>
+          <a:xfrm>
+            <a:off x="731520" y="1645920"/>
+            <a:ext cx="5120640" cy="4572000"/>
+          </a:xfrm>
+          <a:prstGeom prst="roundRect">
+            <a:avLst/>
+          </a:prstGeom>
+          <a:solidFill>
+            <a:srgbClr val="FFFFFF"/>
+          </a:solidFill>
+          <a:ln>
+            <a:solidFill>
+              <a:srgbClr val="E2E8F0"/>
+            </a:solidFill>
+          </a:ln>
+        </p:spPr>
+        <p:style>
+          <a:lnRef idx="1">
+            <a:schemeClr val="accent1"/>
+          </a:lnRef>
+          <a:fillRef idx="3">
+            <a:schemeClr val="accent1"/>
+          </a:fillRef>
+          <a:effectRef idx="2">
+            <a:schemeClr val="accent1"/>
+          </a:effectRef>
+          <a:fontRef idx="minor">
+            <a:schemeClr val="lt1"/>
+          </a:fontRef>
+        </p:style>
+        <p:txBody>
+          <a:bodyPr rtlCol="0" anchor="ctr" wrap="square" lIns="365760" rIns="365760" tIns="365760"/>
+          <a:lstStyle/>
+          <a:p>
+            <a:pPr algn="ctr">
+              <a:defRPr b="1" sz="1200">
+                <a:solidFill>
+                  <a:srgbClr val="DC2626"/>
+                </a:solidFill>
+              </a:defRPr>
+            </a:pPr>
+            <a:r>
+              <a:t>KILL YOUR FIRST IDEA: 3D VR KNOB SIMULATOR</a:t>
+            </a:r>
+          </a:p>
+          <a:p>
+            <a:pPr>
+              <a:spcBef>
+                <a:spcPts val="800"/>
+              </a:spcBef>
+              <a:defRPr sz="1100">
+                <a:solidFill>
+                  <a:srgbClr val="0F172A"/>
+                </a:solidFill>
+              </a:defRPr>
+            </a:pPr>
+            <a:r>
+              <a:t>• First Obvious Idea: Build a 3D Virtual Reality simulator where students walk through an ICU and turn virtual ventilator knobs.</a:t>
+            </a:r>
+          </a:p>
+          <a:p>
+            <a:pPr>
+              <a:spcBef>
+                <a:spcPts val="800"/>
+              </a:spcBef>
+              <a:defRPr sz="1100">
+                <a:solidFill>
+                  <a:srgbClr val="0F172A"/>
+                </a:solidFill>
+              </a:defRPr>
+            </a:pPr>
+            <a:r>
+              <a:t>• Why We Killed It (Evidence-Based):</a:t>
+            </a:r>
+          </a:p>
+          <a:p>
+            <a:pPr>
+              <a:spcBef>
+                <a:spcPts val="800"/>
+              </a:spcBef>
+              <a:defRPr sz="1100">
+                <a:solidFill>
+                  <a:srgbClr val="0F172A"/>
+                </a:solidFill>
+              </a:defRPr>
+            </a:pPr>
+            <a:r>
+              <a:t>• 1. Wrong Problem: Students already touch real ventilators every shift. Their deficit is verbal conceptual reasoning, not motor skills.</a:t>
+            </a:r>
+          </a:p>
+          <a:p>
+            <a:pPr>
+              <a:spcBef>
+                <a:spcPts val="800"/>
+              </a:spcBef>
+              <a:defRPr sz="1100">
+                <a:solidFill>
+                  <a:srgbClr val="0F172A"/>
+                </a:solidFill>
+              </a:defRPr>
+            </a:pPr>
+            <a:r>
+              <a:t>• 2. Cost Barrier: VR headsets and gaming graphics cards are unaffordable for typical government college students.</a:t>
+            </a:r>
+          </a:p>
+          <a:p>
+            <a:pPr>
+              <a:spcBef>
+                <a:spcPts val="800"/>
+              </a:spcBef>
+              <a:defRPr sz="1100">
+                <a:solidFill>
+                  <a:srgbClr val="0F172A"/>
+                </a:solidFill>
+              </a:defRPr>
+            </a:pPr>
+            <a:r>
+              <a:t>• 3. High Friction: Large file downloads and setup time prevent quick 5-minute study sessions during hospital tea breaks.</a:t>
+            </a:r>
+          </a:p>
+        </p:txBody>
+      </p:sp>
+      <p:sp>
+        <p:nvSpPr>
+          <p:cNvPr id="4" name="Rounded Rectangle 3"/>
+          <p:cNvSpPr/>
+          <p:nvPr/>
+        </p:nvSpPr>
+        <p:spPr>
+          <a:xfrm>
+            <a:off x="6217920" y="1645920"/>
+            <a:ext cx="5212080" cy="4572000"/>
+          </a:xfrm>
+          <a:prstGeom prst="roundRect">
+            <a:avLst/>
+          </a:prstGeom>
+          <a:solidFill>
+            <a:srgbClr val="FFFFFF"/>
+          </a:solidFill>
+          <a:ln>
+            <a:solidFill>
+              <a:srgbClr val="E2E8F0"/>
+            </a:solidFill>
+          </a:ln>
+        </p:spPr>
+        <p:style>
+          <a:lnRef idx="1">
+            <a:schemeClr val="accent1"/>
+          </a:lnRef>
+          <a:fillRef idx="3">
+            <a:schemeClr val="accent1"/>
+          </a:fillRef>
+          <a:effectRef idx="2">
+            <a:schemeClr val="accent1"/>
+          </a:effectRef>
+          <a:fontRef idx="minor">
+            <a:schemeClr val="lt1"/>
+          </a:fontRef>
+        </p:style>
+        <p:txBody>
+          <a:bodyPr rtlCol="0" anchor="ctr" wrap="square" lIns="365760" rIns="365760" tIns="365760"/>
+          <a:lstStyle/>
+          <a:p>
+            <a:pPr algn="ctr">
+              <a:defRPr b="1" sz="1200">
+                <a:solidFill>
+                  <a:srgbClr val="0D9488"/>
+                </a:solidFill>
+              </a:defRPr>
+            </a:pPr>
+            <a:r>
+              <a:t>10 IDEAS GENERATED -&gt; SELECTED STRATEGY</a:t>
+            </a:r>
+          </a:p>
+          <a:p>
+            <a:pPr>
+              <a:spcBef>
+                <a:spcPts val="400"/>
+              </a:spcBef>
+              <a:defRPr sz="950">
+                <a:solidFill>
+                  <a:srgbClr val="0F172A"/>
+                </a:solidFill>
+              </a:defRPr>
+            </a:pPr>
+            <a:r>
+              <a:t>• 1. Paper flashcards (Discarded: static, no feedback)</a:t>
+            </a:r>
+          </a:p>
+          <a:p>
+            <a:pPr>
+              <a:spcBef>
+                <a:spcPts val="400"/>
+              </a:spcBef>
+              <a:defRPr sz="950">
+                <a:solidFill>
+                  <a:srgbClr val="0F172A"/>
+                </a:solidFill>
+              </a:defRPr>
+            </a:pPr>
+            <a:r>
+              <a:t>• 2. Heavy Android/iOS app (Discarded: app store barriers)</a:t>
+            </a:r>
+          </a:p>
+          <a:p>
+            <a:pPr>
+              <a:spcBef>
+                <a:spcPts val="400"/>
+              </a:spcBef>
+              <a:defRPr sz="950">
+                <a:solidFill>
+                  <a:srgbClr val="0F172A"/>
+                </a:solidFill>
+              </a:defRPr>
+            </a:pPr>
+            <a:r>
+              <a:t>• 3. Voice-only AI chatbot (Discarded: high latency, poor speech recognition on medical terms in noisy labs)</a:t>
+            </a:r>
+          </a:p>
+          <a:p>
+            <a:pPr>
+              <a:spcBef>
+                <a:spcPts val="400"/>
+              </a:spcBef>
+              <a:defRPr sz="950">
+                <a:solidFill>
+                  <a:srgbClr val="0F172A"/>
+                </a:solidFill>
+              </a:defRPr>
+            </a:pPr>
+            <a:r>
+              <a:t>• 4. Web-based practical viva simulator (SELECTED)</a:t>
+            </a:r>
+          </a:p>
+          <a:p>
+            <a:pPr>
+              <a:spcBef>
+                <a:spcPts val="400"/>
+              </a:spcBef>
+              <a:defRPr sz="950">
+                <a:solidFill>
+                  <a:srgbClr val="0F172A"/>
+                </a:solidFill>
+              </a:defRPr>
+            </a:pPr>
+            <a:r>
+              <a:t>• 5. 3D VR knob simulator (KILLED: wrong problem)</a:t>
+            </a:r>
+          </a:p>
+          <a:p>
+            <a:pPr>
+              <a:spcBef>
+                <a:spcPts val="400"/>
+              </a:spcBef>
+              <a:defRPr sz="950">
+                <a:solidFill>
+                  <a:srgbClr val="0F172A"/>
+                </a:solidFill>
+              </a:defRPr>
+            </a:pPr>
+            <a:r>
+              <a:t>• 6. Peer-to-peer audio calls (Discarded: scheduling conflicts)</a:t>
+            </a:r>
+          </a:p>
+          <a:p>
+            <a:pPr>
+              <a:spcBef>
+                <a:spcPts val="400"/>
+              </a:spcBef>
+              <a:defRPr sz="950">
+                <a:solidFill>
+                  <a:srgbClr val="0F172A"/>
+                </a:solidFill>
+              </a:defRPr>
+            </a:pPr>
+            <a:r>
+              <a:t>• 7. Rule-based targeted gap recommendations (SELECTED)</a:t>
+            </a:r>
+          </a:p>
+          <a:p>
+            <a:pPr>
+              <a:spcBef>
+                <a:spcPts val="400"/>
+              </a:spcBef>
+              <a:defRPr sz="950">
+                <a:solidFill>
+                  <a:srgbClr val="0F172A"/>
+                </a:solidFill>
+              </a:defRPr>
+            </a:pPr>
+            <a:r>
+              <a:t>• 8. Curated 144-question curriculum bank (SELECTED)</a:t>
+            </a:r>
+          </a:p>
+          <a:p>
+            <a:pPr>
+              <a:spcBef>
+                <a:spcPts val="400"/>
+              </a:spcBef>
+              <a:defRPr sz="950">
+                <a:solidFill>
+                  <a:srgbClr val="0F172A"/>
+                </a:solidFill>
+              </a:defRPr>
+            </a:pPr>
+            <a:r>
+              <a:t>• 9. Offline-first intelligence with optional AI (SELECTED)</a:t>
+            </a:r>
+          </a:p>
+          <a:p>
+            <a:pPr>
+              <a:spcBef>
+                <a:spcPts val="400"/>
+              </a:spcBef>
+              <a:defRPr sz="950">
+                <a:solidFill>
+                  <a:srgbClr val="0F172A"/>
+                </a:solidFill>
+              </a:defRPr>
+            </a:pPr>
+            <a:r>
+              <a:t>• 10. Gamified points leaderboard (Deprioritized: distraction)</a:t>
             </a:r>
           </a:p>
         </p:txBody>
@@ -4650,8 +5330,8 @@
         </p:nvSpPr>
         <p:spPr>
           <a:xfrm>
-            <a:off x="731520" y="457200"/>
-            <a:ext cx="10728655" cy="1097280"/>
+            <a:off x="731520" y="365760"/>
+            <a:ext cx="10728655" cy="1005840"/>
           </a:xfrm>
           <a:prstGeom prst="rect">
             <a:avLst/>
@@ -4665,7 +5345,7 @@
           <a:lstStyle/>
           <a:p>
             <a:r>
-              <a:rPr sz="1100" b="1">
+              <a:rPr sz="1000" b="1">
                 <a:solidFill>
                   <a:srgbClr val="0D9488"/>
                 </a:solidFill>
@@ -4675,7 +5355,7 @@
           </a:p>
           <a:p>
             <a:r>
-              <a:rPr sz="2600" b="1">
+              <a:rPr sz="2400" b="1">
                 <a:solidFill>
                   <a:srgbClr val="0F172A"/>
                 </a:solidFill>
@@ -4694,8 +5374,8 @@
           <p:nvPr/>
         </p:nvGraphicFramePr>
         <p:xfrm>
-          <a:off x="731520" y="1828800"/>
-          <a:ext cx="10698480" cy="4389120"/>
+          <a:off x="731520" y="1645920"/>
+          <a:ext cx="10728655" cy="4572000"/>
         </p:xfrm>
         <a:graphic>
           <a:graphicData uri="http://schemas.openxmlformats.org/drawingml/2006/table">
@@ -4704,11 +5384,11 @@
                 <a:tableStyleId>{5C22544A-7EE6-4342-B048-85BDC9FD1C3A}</a:tableStyleId>
               </a:tblPr>
               <a:tblGrid>
-                <a:gridCol w="2286000"/>
-                <a:gridCol w="4023360"/>
-                <a:gridCol w="4389120"/>
+                <a:gridCol w="2011680"/>
+                <a:gridCol w="4114800"/>
+                <a:gridCol w="4602175"/>
               </a:tblGrid>
-              <a:tr h="731520">
+              <a:tr h="571500">
                 <a:tc>
                   <a:txBody>
                     <a:bodyPr/>
@@ -4722,7 +5402,7 @@
                         </a:defRPr>
                       </a:pPr>
                       <a:r>
-                        <a:t>Stakeholder Feedback</a:t>
+                        <a:t>Stakeholder</a:t>
                       </a:r>
                     </a:p>
                   </a:txBody>
@@ -4779,14 +5459,14 @@
                   </a:tcPr>
                 </a:tc>
               </a:tr>
-              <a:tr h="731520">
+              <a:tr h="571500">
                 <a:tc>
                   <a:txBody>
                     <a:bodyPr/>
                     <a:lstStyle/>
                     <a:p>
                       <a:pPr>
-                        <a:defRPr sz="1000">
+                        <a:defRPr sz="950">
                           <a:solidFill>
                             <a:srgbClr val="0F172A"/>
                           </a:solidFill>
@@ -4809,14 +5489,14 @@
                     <a:lstStyle/>
                     <a:p>
                       <a:pPr>
-                        <a:defRPr sz="1000">
+                        <a:defRPr sz="950">
                           <a:solidFill>
                             <a:srgbClr val="0F172A"/>
                           </a:solidFill>
                         </a:defRPr>
                       </a:pPr>
                       <a:r>
-                        <a:t>Dark-mode mobile phones rendered white text on white cards (invisible text).</a:t>
+                        <a:t>Dark-mode mobile phones rendered white font on white cards (invisible text).</a:t>
                       </a:r>
                     </a:p>
                   </a:txBody>
@@ -4832,14 +5512,14 @@
                     <a:lstStyle/>
                     <a:p>
                       <a:pPr>
-                        <a:defRPr sz="1000">
+                        <a:defRPr sz="950">
                           <a:solidFill>
                             <a:srgbClr val="0F172A"/>
                           </a:solidFill>
                         </a:defRPr>
                       </a:pPr>
                       <a:r>
-                        <a:t>Locked .streamlit/config.toml to light base and applied !important dark navy CSS overrides.</a:t>
+                        <a:t>Locked .streamlit/config.toml to light base + enforced dark navy !important CSS typography.</a:t>
                       </a:r>
                     </a:p>
                   </a:txBody>
@@ -4850,14 +5530,14 @@
                   </a:tcPr>
                 </a:tc>
               </a:tr>
-              <a:tr h="731520">
+              <a:tr h="571500">
                 <a:tc>
                   <a:txBody>
                     <a:bodyPr/>
                     <a:lstStyle/>
                     <a:p>
                       <a:pPr>
-                        <a:defRPr sz="1000">
+                        <a:defRPr sz="950">
                           <a:solidFill>
                             <a:srgbClr val="0F172A"/>
                           </a:solidFill>
@@ -4880,14 +5560,14 @@
                     <a:lstStyle/>
                     <a:p>
                       <a:pPr>
-                        <a:defRPr sz="1000">
+                        <a:defRPr sz="950">
                           <a:solidFill>
                             <a:srgbClr val="0F172A"/>
                           </a:solidFill>
                         </a:defRPr>
                       </a:pPr>
                       <a:r>
-                        <a:t>Initial bank had only 2 questions per topic; insufficient for full 2-hour viva.</a:t>
+                        <a:t>Initial bank had only 2 questions per topic; insufficient for full 2-hour viva revision.</a:t>
                       </a:r>
                     </a:p>
                   </a:txBody>
@@ -4903,14 +5583,14 @@
                     <a:lstStyle/>
                     <a:p>
                       <a:pPr>
-                        <a:defRPr sz="1000">
+                        <a:defRPr sz="950">
                           <a:solidFill>
                             <a:srgbClr val="0F172A"/>
                           </a:solidFill>
                         </a:defRPr>
                       </a:pPr>
                       <a:r>
-                        <a:t>Expanded question bank to 144 verified questions (exactly 12 in every topic).</a:t>
+                        <a:t>Expanded question bank to 144 verified questions (exactly 12 in every topic across 12 topics).</a:t>
                       </a:r>
                     </a:p>
                   </a:txBody>
@@ -4921,14 +5601,14 @@
                   </a:tcPr>
                 </a:tc>
               </a:tr>
-              <a:tr h="731520">
+              <a:tr h="571500">
                 <a:tc>
                   <a:txBody>
                     <a:bodyPr/>
                     <a:lstStyle/>
                     <a:p>
                       <a:pPr>
-                        <a:defRPr sz="1000">
+                        <a:defRPr sz="950">
                           <a:solidFill>
                             <a:srgbClr val="0F172A"/>
                           </a:solidFill>
@@ -4951,14 +5631,14 @@
                     <a:lstStyle/>
                     <a:p>
                       <a:pPr>
-                        <a:defRPr sz="1000">
+                        <a:defRPr sz="950">
                           <a:solidFill>
                             <a:srgbClr val="0F172A"/>
                           </a:solidFill>
                         </a:defRPr>
                       </a:pPr>
                       <a:r>
-                        <a:t>Vivas are verbal, not multiple choice! Students freeze when asked to explain aloud.</a:t>
+                        <a:t>Vivas are verbal! Students freeze when asked to formulate an oral answer aloud.</a:t>
                       </a:r>
                     </a:p>
                   </a:txBody>
@@ -4974,14 +5654,14 @@
                     <a:lstStyle/>
                     <a:p>
                       <a:pPr>
-                        <a:defRPr sz="1000">
+                        <a:defRPr sz="950">
                           <a:solidFill>
                             <a:srgbClr val="0F172A"/>
                           </a:solidFill>
                         </a:defRPr>
                       </a:pPr>
                       <a:r>
-                        <a:t>Engineered Quick Viva Mode: students type/draft answers and compare against reference models.</a:t>
+                        <a:t>Engineered Quick Viva Mode: students type/draft answers and compare against reference model answers.</a:t>
                       </a:r>
                     </a:p>
                   </a:txBody>
@@ -4992,14 +5672,14 @@
                   </a:tcPr>
                 </a:tc>
               </a:tr>
-              <a:tr h="731520">
+              <a:tr h="571500">
                 <a:tc>
                   <a:txBody>
                     <a:bodyPr/>
                     <a:lstStyle/>
                     <a:p>
                       <a:pPr>
-                        <a:defRPr sz="1000">
+                        <a:defRPr sz="950">
                           <a:solidFill>
                             <a:srgbClr val="0F172A"/>
                           </a:solidFill>
@@ -5022,14 +5702,14 @@
                     <a:lstStyle/>
                     <a:p>
                       <a:pPr>
-                        <a:defRPr sz="1000">
+                        <a:defRPr sz="950">
                           <a:solidFill>
                             <a:srgbClr val="0F172A"/>
                           </a:solidFill>
                         </a:defRPr>
                       </a:pPr>
                       <a:r>
-                        <a:t>Students had to restart entire 20-question quiz just to review 2 missed mistakes.</a:t>
+                        <a:t>Students had to restart the entire 20-question quiz just to review 2 missed mistakes.</a:t>
                       </a:r>
                     </a:p>
                   </a:txBody>
@@ -5045,7 +5725,7 @@
                     <a:lstStyle/>
                     <a:p>
                       <a:pPr>
-                        <a:defRPr sz="1000">
+                        <a:defRPr sz="950">
                           <a:solidFill>
                             <a:srgbClr val="0F172A"/>
                           </a:solidFill>
@@ -5063,14 +5743,14 @@
                   </a:tcPr>
                 </a:tc>
               </a:tr>
-              <a:tr h="731520">
+              <a:tr h="571500">
                 <a:tc>
                   <a:txBody>
                     <a:bodyPr/>
                     <a:lstStyle/>
                     <a:p>
                       <a:pPr>
-                        <a:defRPr sz="1000">
+                        <a:defRPr sz="950">
                           <a:solidFill>
                             <a:srgbClr val="0F172A"/>
                           </a:solidFill>
@@ -5093,14 +5773,14 @@
                     <a:lstStyle/>
                     <a:p>
                       <a:pPr>
-                        <a:defRPr sz="1000">
+                        <a:defRPr sz="950">
                           <a:solidFill>
                             <a:srgbClr val="0F172A"/>
                           </a:solidFill>
                         </a:defRPr>
                       </a:pPr>
                       <a:r>
-                        <a:t>Hospital basements have zero mobile network; app crashed if API key missing.</a:t>
+                        <a:t>Hospital basements have zero mobile reception; app crashed if API key missing.</a:t>
                       </a:r>
                     </a:p>
                   </a:txBody>
@@ -5116,7 +5796,7 @@
                     <a:lstStyle/>
                     <a:p>
                       <a:pPr>
-                        <a:defRPr sz="1000">
+                        <a:defRPr sz="950">
                           <a:solidFill>
                             <a:srgbClr val="0F172A"/>
                           </a:solidFill>
@@ -5124,6 +5804,148 @@
                       </a:pPr>
                       <a:r>
                         <a:t>Built Offline-First Knowledge Engine searching local verified records with zero crash risk.</a:t>
+                      </a:r>
+                    </a:p>
+                  </a:txBody>
+                  <a:tcPr>
+                    <a:solidFill>
+                      <a:srgbClr val="F8FAFC"/>
+                    </a:solidFill>
+                  </a:tcPr>
+                </a:tc>
+              </a:tr>
+              <a:tr h="571500">
+                <a:tc>
+                  <a:txBody>
+                    <a:bodyPr/>
+                    <a:lstStyle/>
+                    <a:p>
+                      <a:pPr>
+                        <a:defRPr sz="950">
+                          <a:solidFill>
+                            <a:srgbClr val="0F172A"/>
+                          </a:solidFill>
+                        </a:defRPr>
+                      </a:pPr>
+                      <a:r>
+                        <a:t>Preethi (Resp. Care)</a:t>
+                      </a:r>
+                    </a:p>
+                  </a:txBody>
+                  <a:tcPr>
+                    <a:solidFill>
+                      <a:srgbClr val="FFFFFF"/>
+                    </a:solidFill>
+                  </a:tcPr>
+                </a:tc>
+                <a:tc>
+                  <a:txBody>
+                    <a:bodyPr/>
+                    <a:lstStyle/>
+                    <a:p>
+                      <a:pPr>
+                        <a:defRPr sz="950">
+                          <a:solidFill>
+                            <a:srgbClr val="0F172A"/>
+                          </a:solidFill>
+                        </a:defRPr>
+                      </a:pPr>
+                      <a:r>
+                        <a:t>Students panic because external examiners rush them; untimed quizzes don't prepare for viva.</a:t>
+                      </a:r>
+                    </a:p>
+                  </a:txBody>
+                  <a:tcPr>
+                    <a:solidFill>
+                      <a:srgbClr val="FFFFFF"/>
+                    </a:solidFill>
+                  </a:tcPr>
+                </a:tc>
+                <a:tc>
+                  <a:txBody>
+                    <a:bodyPr/>
+                    <a:lstStyle/>
+                    <a:p>
+                      <a:pPr>
+                        <a:defRPr sz="950">
+                          <a:solidFill>
+                            <a:srgbClr val="0F172A"/>
+                          </a:solidFill>
+                        </a:defRPr>
+                      </a:pPr>
+                      <a:r>
+                        <a:t>Engineered 30-Second Examiner Pressure Mode: Rapid countdown timer with red urgency alerts.</a:t>
+                      </a:r>
+                    </a:p>
+                  </a:txBody>
+                  <a:tcPr>
+                    <a:solidFill>
+                      <a:srgbClr val="FFFFFF"/>
+                    </a:solidFill>
+                  </a:tcPr>
+                </a:tc>
+              </a:tr>
+              <a:tr h="571500">
+                <a:tc>
+                  <a:txBody>
+                    <a:bodyPr/>
+                    <a:lstStyle/>
+                    <a:p>
+                      <a:pPr>
+                        <a:defRPr sz="950">
+                          <a:solidFill>
+                            <a:srgbClr val="0F172A"/>
+                          </a:solidFill>
+                        </a:defRPr>
+                      </a:pPr>
+                      <a:r>
+                        <a:t>Tharun (Resp. Care)</a:t>
+                      </a:r>
+                    </a:p>
+                  </a:txBody>
+                  <a:tcPr>
+                    <a:solidFill>
+                      <a:srgbClr val="F8FAFC"/>
+                    </a:solidFill>
+                  </a:tcPr>
+                </a:tc>
+                <a:tc>
+                  <a:txBody>
+                    <a:bodyPr/>
+                    <a:lstStyle/>
+                    <a:p>
+                      <a:pPr>
+                        <a:defRPr sz="950">
+                          <a:solidFill>
+                            <a:srgbClr val="0F172A"/>
+                          </a:solidFill>
+                        </a:defRPr>
+                      </a:pPr>
+                      <a:r>
+                        <a:t>Students cannot take laptops/phones into the viva examination waiting hall.</a:t>
+                      </a:r>
+                    </a:p>
+                  </a:txBody>
+                  <a:tcPr>
+                    <a:solidFill>
+                      <a:srgbClr val="F8FAFC"/>
+                    </a:solidFill>
+                  </a:tcPr>
+                </a:tc>
+                <a:tc>
+                  <a:txBody>
+                    <a:bodyPr/>
+                    <a:lstStyle/>
+                    <a:p>
+                      <a:pPr>
+                        <a:defRPr sz="950">
+                          <a:solidFill>
+                            <a:srgbClr val="0F172A"/>
+                          </a:solidFill>
+                        </a:defRPr>
+                      </a:pPr>
+                      <a:r>
+                        <a:t>Engineered 1-Click Pocket Viva Cram Sheet Generator creating printable 2-page .docx summaries.</a:t>
                       </a:r>
                     </a:p>
                   </a:txBody>
@@ -5164,8 +5986,8 @@
         </p:nvSpPr>
         <p:spPr>
           <a:xfrm>
-            <a:off x="731520" y="457200"/>
-            <a:ext cx="10728655" cy="1097280"/>
+            <a:off x="731520" y="365760"/>
+            <a:ext cx="10728655" cy="1005840"/>
           </a:xfrm>
           <a:prstGeom prst="rect">
             <a:avLst/>
@@ -5179,7 +6001,7 @@
           <a:lstStyle/>
           <a:p>
             <a:r>
-              <a:rPr sz="1100" b="1">
+              <a:rPr sz="1000" b="1">
                 <a:solidFill>
                   <a:srgbClr val="0D9488"/>
                 </a:solidFill>
@@ -5189,7 +6011,7 @@
           </a:p>
           <a:p>
             <a:r>
-              <a:rPr sz="2600" b="1">
+              <a:rPr sz="2400" b="1">
                 <a:solidFill>
                   <a:srgbClr val="0F172A"/>
                 </a:solidFill>
@@ -5207,8 +6029,8 @@
         </p:nvSpPr>
         <p:spPr>
           <a:xfrm>
-            <a:off x="914400" y="1828800"/>
-            <a:ext cx="10332720" cy="4389120"/>
+            <a:off x="731520" y="1645920"/>
+            <a:ext cx="10728655" cy="4572000"/>
           </a:xfrm>
           <a:prstGeom prst="roundRect">
             <a:avLst/>
@@ -5237,26 +6059,26 @@
           </a:fontRef>
         </p:style>
         <p:txBody>
-          <a:bodyPr rtlCol="0" anchor="ctr" wrap="square" lIns="457200" rIns="457200" tIns="457200"/>
+          <a:bodyPr rtlCol="0" anchor="ctr" wrap="square" lIns="365760" rIns="365760" tIns="365760"/>
           <a:lstStyle/>
           <a:p>
             <a:pPr algn="ctr">
-              <a:defRPr b="1" sz="1400">
+              <a:defRPr b="1" sz="1300">
                 <a:solidFill>
                   <a:srgbClr val="0D9488"/>
                 </a:solidFill>
               </a:defRPr>
             </a:pPr>
             <a:r>
-              <a:t>MEDSKILL AI — PRODUCTION PLATFORM SUMMARY</a:t>
+              <a:t>MEDSKILL AI — PRODUCTION PLATFORM &amp; NEW FEATURE SUITE</a:t>
             </a:r>
           </a:p>
           <a:p>
             <a:pPr>
               <a:spcBef>
-                <a:spcPts val="800"/>
+                <a:spcPts val="600"/>
               </a:spcBef>
-              <a:defRPr sz="1200">
+              <a:defRPr sz="1100">
                 <a:solidFill>
                   <a:srgbClr val="0F172A"/>
                 </a:solidFill>
@@ -5269,91 +6091,106 @@
           <a:p>
             <a:pPr>
               <a:spcBef>
-                <a:spcPts val="800"/>
+                <a:spcPts val="600"/>
               </a:spcBef>
-              <a:defRPr sz="1200">
+              <a:defRPr sz="1100">
                 <a:solidFill>
                   <a:srgbClr val="0F172A"/>
                 </a:solidFill>
               </a:defRPr>
             </a:pPr>
             <a:r>
-              <a:t>• 144 Reviewed Viva Questions: Balanced across 12 topics in Respiratory, Anaesthesia, and Dialysis technology (12 per topic).</a:t>
+              <a:t>• 144 Verified Curriculum Questions: Exactly 12 questions in each of the 12 core topics across Respiratory Therapy, Anaesthesia, and Dialysis technology.</a:t>
             </a:r>
           </a:p>
           <a:p>
             <a:pPr>
               <a:spcBef>
-                <a:spcPts val="800"/>
+                <a:spcPts val="600"/>
               </a:spcBef>
-              <a:defRPr sz="1200">
+              <a:defRPr sz="1100">
                 <a:solidFill>
                   <a:srgbClr val="0F172A"/>
                 </a:solidFill>
               </a:defRPr>
             </a:pPr>
             <a:r>
-              <a:t>• Dual-Mode Training: Seamlessly switch between Objective MCQ practice and Spoken Quick Viva self-evaluation.</a:t>
+              <a:t>• Dual-Mode Simulation: Seamlessly switch between Objective MCQ practice and Spoken Quick Viva self-evaluation against reference instructor models.</a:t>
             </a:r>
           </a:p>
           <a:p>
             <a:pPr>
               <a:spcBef>
-                <a:spcPts val="800"/>
+                <a:spcPts val="600"/>
               </a:spcBef>
-              <a:defRPr sz="1200">
+              <a:defRPr sz="1100">
                 <a:solidFill>
                   <a:srgbClr val="0F172A"/>
                 </a:solidFill>
               </a:defRPr>
             </a:pPr>
             <a:r>
-              <a:t>• Instant Diagnostic Feedback: Detailed clinical explanations + expandable 'Key Viva Revision Points' buzzword cards.</a:t>
+              <a:t>• NEW: 30-Second Examiner Pressure Mode: Rapid countdown timer injecting realistic exam-hall urgency with visual color changes.</a:t>
             </a:r>
           </a:p>
           <a:p>
             <a:pPr>
               <a:spcBef>
-                <a:spcPts val="800"/>
+                <a:spcPts val="600"/>
               </a:spcBef>
-              <a:defRPr sz="1200">
+              <a:defRPr sz="1100">
                 <a:solidFill>
                   <a:srgbClr val="0F172A"/>
                 </a:solidFill>
               </a:defRPr>
             </a:pPr>
             <a:r>
-              <a:t>• Targeted Remediation: Rule-based study recommendations with 1-click retry on missed items.</a:t>
+              <a:t>• NEW: 1-Click Pocket Viva Cram Sheet Generator: Produces compact, printable .docx cheat-sheets summarizing high-yield clinical rules &amp; missed questions.</a:t>
             </a:r>
           </a:p>
           <a:p>
             <a:pPr>
               <a:spcBef>
-                <a:spcPts val="800"/>
+                <a:spcPts val="600"/>
               </a:spcBef>
-              <a:defRPr sz="1200">
+              <a:defRPr sz="1100">
                 <a:solidFill>
                   <a:srgbClr val="0F172A"/>
                 </a:solidFill>
               </a:defRPr>
             </a:pPr>
             <a:r>
-              <a:t>• Ethical &amp; Operational Safety: 100% offline-first resilience; zero clinical prescribing; no patient data collected.</a:t>
+              <a:t>• NEW: 1-Click Quick Retry Quiz: Automatically isolates failed items so students can immediately achieve 100% mastery.</a:t>
             </a:r>
           </a:p>
           <a:p>
             <a:pPr>
               <a:spcBef>
-                <a:spcPts val="800"/>
+                <a:spcPts val="600"/>
               </a:spcBef>
-              <a:defRPr sz="1200">
+              <a:defRPr sz="1100">
                 <a:solidFill>
                   <a:srgbClr val="0F172A"/>
                 </a:solidFill>
               </a:defRPr>
             </a:pPr>
             <a:r>
-              <a:t>• Impact: Transforms passive textbook memorization into active verbal confidence for university clinical examinations.</a:t>
+              <a:t>• 100% Offline-First Architecture: Tier 1 local knowledge engine runs without internet or API keys; Tier 2 provides optional Gemini integration.</a:t>
+            </a:r>
+          </a:p>
+          <a:p>
+            <a:pPr>
+              <a:spcBef>
+                <a:spcPts val="600"/>
+              </a:spcBef>
+              <a:defRPr sz="1100">
+                <a:solidFill>
+                  <a:srgbClr val="0F172A"/>
+                </a:solidFill>
+              </a:defRPr>
+            </a:pPr>
+            <a:r>
+              <a:t>• Verified Impact: Tested with 8 core student stakeholders (Riddhi, Siddhi, Naziya, Preethi, Bhargav, Naveen, Tharun, Atharv) + 6 peer technologists.</a:t>
             </a:r>
           </a:p>
         </p:txBody>

</xml_diff>